<commit_message>
Fold robotic platforms into a one-line note and rebalance poster layout
Co-Authored-By: Claude Opus 5.5 <noreply@anthropic.com>
Claude-Session: https://claude.ai/code/session_01MfhLusbbFu3z4J6aTCZXt3
</commit_message>
<xml_diff>
--- a/poster/IHPBA2026_RDP_ePoster.pptx
+++ b/poster/IHPBA2026_RDP_ePoster.pptx
@@ -6074,7 +6074,7 @@
         <p:spPr>
           <a:xfrm>
             <a:off x="530352" y="4681728"/>
-            <a:ext cx="4681728" cy="1463040"/>
+            <a:ext cx="4681728" cy="1828800"/>
           </a:xfrm>
         </p:spPr>
         <p:txBody>
@@ -6097,7 +6097,7 @@
               <a:buChar char="•"/>
             </a:pPr>
             <a:r>
-              <a:rPr lang="en-US" sz="1200" dirty="0"/>
+              <a:rPr lang="en-US" sz="1350" dirty="0"/>
               <a:t>Distal pancreatectomy has shifted from open (ODP) to minimally invasive surgery: laparoscopic (LDP, since 1994) and robotic (RDP).</a:t>
             </a:r>
           </a:p>
@@ -6116,15 +6116,15 @@
               <a:buChar char="•"/>
             </a:pPr>
             <a:r>
-              <a:rPr lang="en-US" sz="1200" dirty="0"/>
+              <a:rPr lang="en-US" sz="1350" dirty="0"/>
               <a:t xml:space="preserve">LDP is established but limited by </a:t>
             </a:r>
             <a:r>
-              <a:rPr lang="en-US" sz="1200" b="1" dirty="0"/>
+              <a:rPr lang="en-US" sz="1350" b="1" dirty="0"/>
               <a:t>dexterity and visualisation</a:t>
             </a:r>
             <a:r>
-              <a:rPr lang="en-US" sz="1200" dirty="0"/>
+              <a:rPr lang="en-US" sz="1350" dirty="0"/>
               <a:t>.</a:t>
             </a:r>
           </a:p>
@@ -6143,7 +6143,7 @@
               <a:buChar char="•"/>
             </a:pPr>
             <a:r>
-              <a:rPr lang="en-US" sz="1200" dirty="0"/>
+              <a:rPr lang="en-US" sz="1350" dirty="0"/>
               <a:t>RDP addresses these limits, yet whether it improves outcomes over LDP remains unsettled.</a:t>
             </a:r>
           </a:p>
@@ -6157,8 +6157,8 @@
         </p:nvSpPr>
         <p:spPr>
           <a:xfrm>
-            <a:off x="530352" y="6217920"/>
-            <a:ext cx="4681728" cy="841248"/>
+            <a:off x="530352" y="6556248"/>
+            <a:ext cx="4681728" cy="1005840"/>
           </a:xfrm>
           <a:prstGeom prst="roundRect">
             <a:avLst>
@@ -6188,7 +6188,7 @@
               <a:buNone/>
             </a:pPr>
             <a:r>
-              <a:rPr lang="en-US" sz="1200" b="1" dirty="0">
+              <a:rPr lang="en-US" sz="1350" b="1" dirty="0">
                 <a:solidFill>
                   <a:srgbClr val="213C80"/>
                 </a:solidFill>
@@ -6196,7 +6196,7 @@
               <a:t xml:space="preserve">AIM  </a:t>
             </a:r>
             <a:r>
-              <a:rPr lang="en-US" sz="1200" dirty="0"/>
+              <a:rPr lang="en-US" sz="1350" dirty="0"/>
               <a:t>A clinical review comparing RDP with ODP and LDP: technique, clinical outcomes, cost-effectiveness and challenges.</a:t>
             </a:r>
           </a:p>
@@ -6204,22 +6204,25 @@
       </p:sp>
       <p:sp>
         <p:nvSpPr>
-          <p:cNvPr id="107" name="Section Title 32"/>
-          <p:cNvSpPr>
-            <a:spLocks noGrp="1"/>
-          </p:cNvSpPr>
-          <p:nvPr>
-            <p:ph type="body" sz="quarter" idx="32"/>
-          </p:nvPr>
+          <p:cNvPr id="107" name="Section Title Advantages"/>
+          <p:cNvSpPr txBox="1"/>
+          <p:nvPr/>
         </p:nvSpPr>
         <p:spPr>
           <a:xfrm>
-            <a:off x="530352" y="7333488"/>
+            <a:off x="530352" y="7882128"/>
             <a:ext cx="4681728" cy="384048"/>
           </a:xfrm>
+          <a:prstGeom prst="rect">
+            <a:avLst/>
+          </a:prstGeom>
+          <a:noFill/>
+          <a:ln>
+            <a:noFill/>
+          </a:ln>
         </p:spPr>
         <p:txBody>
-          <a:bodyPr anchor="ctr">
+          <a:bodyPr wrap="square" lIns="0" tIns="0" rIns="0" bIns="0" anchor="ctr">
             <a:noAutofit/>
           </a:bodyPr>
           <a:lstStyle/>
@@ -6234,46 +6237,336 @@
               <a:buNone/>
             </a:pPr>
             <a:r>
-              <a:rPr lang="en-US" dirty="0"/>
-              <a:t>OPERATIVE TECHNIQUE</a:t>
+              <a:rPr lang="en-US" sz="1548" b="1" dirty="0">
+                <a:solidFill>
+                  <a:srgbClr val="213C80"/>
+                </a:solidFill>
+              </a:rPr>
+              <a:t>WHY ROBOTIC?</a:t>
             </a:r>
           </a:p>
         </p:txBody>
       </p:sp>
-      <p:pic>
-        <p:nvPicPr>
-          <p:cNvPr id="108" name="Figure 1" descr="Port placement for robotic distal pancreatectomy"/>
-          <p:cNvPicPr>
-            <a:picLocks noChangeAspect="1"/>
-          </p:cNvPicPr>
-          <p:nvPr/>
-        </p:nvPicPr>
-        <p:blipFill>
-          <a:blip r:embed="rIdFig"/>
-          <a:stretch>
-            <a:fillRect/>
-          </a:stretch>
-        </p:blipFill>
-        <p:spPr>
-          <a:xfrm>
-            <a:off x="530352" y="7808976"/>
-            <a:ext cx="1874520" cy="2091341"/>
-          </a:xfrm>
-          <a:prstGeom prst="rect">
-            <a:avLst/>
-          </a:prstGeom>
-        </p:spPr>
-      </p:pic>
       <p:sp>
         <p:nvSpPr>
-          <p:cNvPr id="109" name="Fig caption"/>
+          <p:cNvPr id="108" name="Advantage 3D"/>
           <p:cNvSpPr txBox="1"/>
           <p:nvPr/>
         </p:nvSpPr>
         <p:spPr>
           <a:xfrm>
-            <a:off x="530352" y="9936893"/>
-            <a:ext cx="1874520" cy="566928"/>
+            <a:off x="530352" y="8357616"/>
+            <a:ext cx="1067562" cy="1051560"/>
+          </a:xfrm>
+          <a:prstGeom prst="roundRect">
+            <a:avLst>
+              <a:gd name="adj" fmla="val 14000"/>
+            </a:avLst>
+          </a:prstGeom>
+          <a:solidFill>
+            <a:srgbClr val="EEF1F8"/>
+          </a:solidFill>
+          <a:ln>
+            <a:noFill/>
+          </a:ln>
+        </p:spPr>
+        <p:txBody>
+          <a:bodyPr wrap="square" lIns="36576" tIns="36576" rIns="36576" bIns="36576" anchor="ctr">
+            <a:noAutofit/>
+          </a:bodyPr>
+          <a:lstStyle/>
+          <a:p>
+            <a:pPr algn="ctr" marL="0" indent="0">
+              <a:spcBef>
+                <a:spcPts val="0"/>
+              </a:spcBef>
+              <a:spcAft>
+                <a:spcPts val="100"/>
+              </a:spcAft>
+              <a:buNone/>
+            </a:pPr>
+            <a:r>
+              <a:rPr lang="en-US" sz="1600" b="1" dirty="0">
+                <a:solidFill>
+                  <a:srgbClr val="213C80"/>
+                </a:solidFill>
+              </a:rPr>
+              <a:t>3D</a:t>
+            </a:r>
+          </a:p>
+          <a:p>
+            <a:pPr algn="ctr" marL="0" indent="0">
+              <a:spcBef>
+                <a:spcPts val="0"/>
+              </a:spcBef>
+              <a:spcAft>
+                <a:spcPts val="0"/>
+              </a:spcAft>
+              <a:buNone/>
+            </a:pPr>
+            <a:r>
+              <a:rPr lang="en-US" sz="1150" dirty="0">
+                <a:solidFill>
+                  <a:srgbClr val="5B6170"/>
+                </a:solidFill>
+              </a:rPr>
+              <a:t>magnified</a:t>
+            </a:r>
+          </a:p>
+          <a:p>
+            <a:pPr algn="ctr" marL="0" indent="0">
+              <a:spcBef>
+                <a:spcPts val="0"/>
+              </a:spcBef>
+              <a:spcAft>
+                <a:spcPts val="0"/>
+              </a:spcAft>
+              <a:buNone/>
+            </a:pPr>
+            <a:r>
+              <a:rPr lang="en-US" sz="1150" dirty="0">
+                <a:solidFill>
+                  <a:srgbClr val="5B6170"/>
+                </a:solidFill>
+              </a:rPr>
+              <a:t>visualisation</a:t>
+            </a:r>
+          </a:p>
+        </p:txBody>
+      </p:sp>
+      <p:sp>
+        <p:nvSpPr>
+          <p:cNvPr id="109" name="Advantage Tremor"/>
+          <p:cNvSpPr txBox="1"/>
+          <p:nvPr/>
+        </p:nvSpPr>
+        <p:spPr>
+          <a:xfrm>
+            <a:off x="1735074" y="8357616"/>
+            <a:ext cx="1067562" cy="1051560"/>
+          </a:xfrm>
+          <a:prstGeom prst="roundRect">
+            <a:avLst>
+              <a:gd name="adj" fmla="val 14000"/>
+            </a:avLst>
+          </a:prstGeom>
+          <a:solidFill>
+            <a:srgbClr val="EEF1F8"/>
+          </a:solidFill>
+          <a:ln>
+            <a:noFill/>
+          </a:ln>
+        </p:spPr>
+        <p:txBody>
+          <a:bodyPr wrap="square" lIns="36576" tIns="36576" rIns="36576" bIns="36576" anchor="ctr">
+            <a:noAutofit/>
+          </a:bodyPr>
+          <a:lstStyle/>
+          <a:p>
+            <a:pPr algn="ctr" marL="0" indent="0">
+              <a:spcBef>
+                <a:spcPts val="0"/>
+              </a:spcBef>
+              <a:spcAft>
+                <a:spcPts val="100"/>
+              </a:spcAft>
+              <a:buNone/>
+            </a:pPr>
+            <a:r>
+              <a:rPr lang="en-US" sz="1600" b="1" dirty="0">
+                <a:solidFill>
+                  <a:srgbClr val="213C80"/>
+                </a:solidFill>
+              </a:rPr>
+              <a:t>Tremor</a:t>
+            </a:r>
+          </a:p>
+          <a:p>
+            <a:pPr algn="ctr" marL="0" indent="0">
+              <a:spcBef>
+                <a:spcPts val="0"/>
+              </a:spcBef>
+              <a:spcAft>
+                <a:spcPts val="0"/>
+              </a:spcAft>
+              <a:buNone/>
+            </a:pPr>
+            <a:r>
+              <a:rPr lang="en-US" sz="1150" dirty="0">
+                <a:solidFill>
+                  <a:srgbClr val="5B6170"/>
+                </a:solidFill>
+              </a:rPr>
+              <a:t>filtration</a:t>
+            </a:r>
+          </a:p>
+        </p:txBody>
+      </p:sp>
+      <p:sp>
+        <p:nvSpPr>
+          <p:cNvPr id="110" name="Advantage Motion"/>
+          <p:cNvSpPr txBox="1"/>
+          <p:nvPr/>
+        </p:nvSpPr>
+        <p:spPr>
+          <a:xfrm>
+            <a:off x="2939796" y="8357616"/>
+            <a:ext cx="1067562" cy="1051560"/>
+          </a:xfrm>
+          <a:prstGeom prst="roundRect">
+            <a:avLst>
+              <a:gd name="adj" fmla="val 14000"/>
+            </a:avLst>
+          </a:prstGeom>
+          <a:solidFill>
+            <a:srgbClr val="EEF1F8"/>
+          </a:solidFill>
+          <a:ln>
+            <a:noFill/>
+          </a:ln>
+        </p:spPr>
+        <p:txBody>
+          <a:bodyPr wrap="square" lIns="36576" tIns="36576" rIns="36576" bIns="36576" anchor="ctr">
+            <a:noAutofit/>
+          </a:bodyPr>
+          <a:lstStyle/>
+          <a:p>
+            <a:pPr algn="ctr" marL="0" indent="0">
+              <a:spcBef>
+                <a:spcPts val="0"/>
+              </a:spcBef>
+              <a:spcAft>
+                <a:spcPts val="100"/>
+              </a:spcAft>
+              <a:buNone/>
+            </a:pPr>
+            <a:r>
+              <a:rPr lang="en-US" sz="1600" b="1" dirty="0">
+                <a:solidFill>
+                  <a:srgbClr val="213C80"/>
+                </a:solidFill>
+              </a:rPr>
+              <a:t>Motion</a:t>
+            </a:r>
+          </a:p>
+          <a:p>
+            <a:pPr algn="ctr" marL="0" indent="0">
+              <a:spcBef>
+                <a:spcPts val="0"/>
+              </a:spcBef>
+              <a:spcAft>
+                <a:spcPts val="0"/>
+              </a:spcAft>
+              <a:buNone/>
+            </a:pPr>
+            <a:r>
+              <a:rPr lang="en-US" sz="1150" dirty="0">
+                <a:solidFill>
+                  <a:srgbClr val="5B6170"/>
+                </a:solidFill>
+              </a:rPr>
+              <a:t>scaling</a:t>
+            </a:r>
+          </a:p>
+        </p:txBody>
+      </p:sp>
+      <p:sp>
+        <p:nvSpPr>
+          <p:cNvPr id="111" name="Advantage Wristed"/>
+          <p:cNvSpPr txBox="1"/>
+          <p:nvPr/>
+        </p:nvSpPr>
+        <p:spPr>
+          <a:xfrm>
+            <a:off x="4144518" y="8357616"/>
+            <a:ext cx="1067562" cy="1051560"/>
+          </a:xfrm>
+          <a:prstGeom prst="roundRect">
+            <a:avLst>
+              <a:gd name="adj" fmla="val 14000"/>
+            </a:avLst>
+          </a:prstGeom>
+          <a:solidFill>
+            <a:srgbClr val="EEF1F8"/>
+          </a:solidFill>
+          <a:ln>
+            <a:noFill/>
+          </a:ln>
+        </p:spPr>
+        <p:txBody>
+          <a:bodyPr wrap="square" lIns="36576" tIns="36576" rIns="36576" bIns="36576" anchor="ctr">
+            <a:noAutofit/>
+          </a:bodyPr>
+          <a:lstStyle/>
+          <a:p>
+            <a:pPr algn="ctr" marL="0" indent="0">
+              <a:spcBef>
+                <a:spcPts val="0"/>
+              </a:spcBef>
+              <a:spcAft>
+                <a:spcPts val="100"/>
+              </a:spcAft>
+              <a:buNone/>
+            </a:pPr>
+            <a:r>
+              <a:rPr lang="en-US" sz="1600" b="1" dirty="0">
+                <a:solidFill>
+                  <a:srgbClr val="213C80"/>
+                </a:solidFill>
+              </a:rPr>
+              <a:t>Wristed</a:t>
+            </a:r>
+          </a:p>
+          <a:p>
+            <a:pPr algn="ctr" marL="0" indent="0">
+              <a:spcBef>
+                <a:spcPts val="0"/>
+              </a:spcBef>
+              <a:spcAft>
+                <a:spcPts val="0"/>
+              </a:spcAft>
+              <a:buNone/>
+            </a:pPr>
+            <a:r>
+              <a:rPr lang="en-US" sz="1150" dirty="0">
+                <a:solidFill>
+                  <a:srgbClr val="5B6170"/>
+                </a:solidFill>
+              </a:rPr>
+              <a:t>articulating</a:t>
+            </a:r>
+          </a:p>
+          <a:p>
+            <a:pPr algn="ctr" marL="0" indent="0">
+              <a:spcBef>
+                <a:spcPts val="0"/>
+              </a:spcBef>
+              <a:spcAft>
+                <a:spcPts val="0"/>
+              </a:spcAft>
+              <a:buNone/>
+            </a:pPr>
+            <a:r>
+              <a:rPr lang="en-US" sz="1150" dirty="0">
+                <a:solidFill>
+                  <a:srgbClr val="5B6170"/>
+                </a:solidFill>
+              </a:rPr>
+              <a:t>instruments</a:t>
+            </a:r>
+          </a:p>
+        </p:txBody>
+      </p:sp>
+      <p:sp>
+        <p:nvSpPr>
+          <p:cNvPr id="112" name="Platforms note"/>
+          <p:cNvSpPr txBox="1"/>
+          <p:nvPr/>
+        </p:nvSpPr>
+        <p:spPr>
+          <a:xfrm>
+            <a:off x="530352" y="9518904"/>
+            <a:ext cx="4681728" cy="594360"/>
           </a:xfrm>
           <a:prstGeom prst="rect">
             <a:avLst/>
@@ -6289,6 +6582,56 @@
           </a:bodyPr>
           <a:lstStyle/>
           <a:p>
+            <a:pPr marL="0" indent="0">
+              <a:spcBef>
+                <a:spcPts val="0"/>
+              </a:spcBef>
+              <a:spcAft>
+                <a:spcPts val="0"/>
+              </a:spcAft>
+              <a:buNone/>
+            </a:pPr>
+            <a:r>
+              <a:rPr lang="en-US" sz="1200" b="1" dirty="0">
+                <a:solidFill>
+                  <a:srgbClr val="213C80"/>
+                </a:solidFill>
+              </a:rPr>
+              <a:t xml:space="preserve">Platforms: </a:t>
+            </a:r>
+            <a:r>
+              <a:rPr lang="en-US" sz="1200" dirty="0">
+                <a:solidFill>
+                  <a:srgbClr val="5B6170"/>
+                </a:solidFill>
+              </a:rPr>
+              <a:t>almost all evidence is from da Vinci; Versius and hinotori™ have only early case reports, and none yet for Hugo.</a:t>
+            </a:r>
+          </a:p>
+        </p:txBody>
+      </p:sp>
+      <p:sp>
+        <p:nvSpPr>
+          <p:cNvPr id="113" name="Section Title 32"/>
+          <p:cNvSpPr>
+            <a:spLocks noGrp="1"/>
+          </p:cNvSpPr>
+          <p:nvPr>
+            <p:ph type="body" sz="quarter" idx="32"/>
+          </p:nvPr>
+        </p:nvSpPr>
+        <p:spPr>
+          <a:xfrm>
+            <a:off x="530352" y="10479024"/>
+            <a:ext cx="4681728" cy="384048"/>
+          </a:xfrm>
+        </p:spPr>
+        <p:txBody>
+          <a:bodyPr anchor="ctr">
+            <a:noAutofit/>
+          </a:bodyPr>
+          <a:lstStyle/>
+          <a:p>
             <a:pPr algn="ctr" marL="0" indent="0">
               <a:spcBef>
                 <a:spcPts val="0"/>
@@ -6299,11 +6642,76 @@
               <a:buNone/>
             </a:pPr>
             <a:r>
-              <a:rPr lang="en-US" sz="1000" b="1" dirty="0"/>
+              <a:rPr lang="en-US" dirty="0"/>
+              <a:t>OPERATIVE TECHNIQUE</a:t>
+            </a:r>
+          </a:p>
+        </p:txBody>
+      </p:sp>
+      <p:pic>
+        <p:nvPicPr>
+          <p:cNvPr id="114" name="Figure 1" descr="Port placement for robotic distal pancreatectomy"/>
+          <p:cNvPicPr>
+            <a:picLocks noChangeAspect="1"/>
+          </p:cNvPicPr>
+          <p:nvPr/>
+        </p:nvPicPr>
+        <p:blipFill>
+          <a:blip r:embed="rIdFig"/>
+          <a:stretch>
+            <a:fillRect/>
+          </a:stretch>
+        </p:blipFill>
+        <p:spPr>
+          <a:xfrm>
+            <a:off x="530352" y="10954512"/>
+            <a:ext cx="2148840" cy="2397391"/>
+          </a:xfrm>
+          <a:prstGeom prst="rect">
+            <a:avLst/>
+          </a:prstGeom>
+        </p:spPr>
+      </p:pic>
+      <p:sp>
+        <p:nvSpPr>
+          <p:cNvPr id="115" name="Fig caption"/>
+          <p:cNvSpPr txBox="1"/>
+          <p:nvPr/>
+        </p:nvSpPr>
+        <p:spPr>
+          <a:xfrm>
+            <a:off x="530352" y="13388479"/>
+            <a:ext cx="2148840" cy="685800"/>
+          </a:xfrm>
+          <a:prstGeom prst="rect">
+            <a:avLst/>
+          </a:prstGeom>
+          <a:noFill/>
+          <a:ln>
+            <a:noFill/>
+          </a:ln>
+        </p:spPr>
+        <p:txBody>
+          <a:bodyPr wrap="square" lIns="0" tIns="0" rIns="0" bIns="0" anchor="t">
+            <a:noAutofit/>
+          </a:bodyPr>
+          <a:lstStyle/>
+          <a:p>
+            <a:pPr algn="ctr" marL="0" indent="0">
+              <a:spcBef>
+                <a:spcPts val="0"/>
+              </a:spcBef>
+              <a:spcAft>
+                <a:spcPts val="0"/>
+              </a:spcAft>
+              <a:buNone/>
+            </a:pPr>
+            <a:r>
+              <a:rPr lang="en-US" sz="1100" b="1" dirty="0"/>
               <a:t xml:space="preserve">Fig. 1 </a:t>
             </a:r>
             <a:r>
-              <a:rPr lang="en-US" sz="1000" dirty="0">
+              <a:rPr lang="en-US" sz="1100" dirty="0">
                 <a:solidFill>
                   <a:srgbClr val="5B6170"/>
                 </a:solidFill>
@@ -6315,7 +6723,7 @@
       </p:sp>
       <p:sp>
         <p:nvSpPr>
-          <p:cNvPr id="110" name="Technique Steps"/>
+          <p:cNvPr id="116" name="Technique Steps"/>
           <p:cNvSpPr>
             <a:spLocks noGrp="1"/>
           </p:cNvSpPr>
@@ -6325,8 +6733,8 @@
         </p:nvSpPr>
         <p:spPr>
           <a:xfrm>
-            <a:off x="2569464" y="7808976"/>
-            <a:ext cx="2642616" cy="2331720"/>
+            <a:off x="2843784" y="10954512"/>
+            <a:ext cx="2368296" cy="2743200"/>
           </a:xfrm>
         </p:spPr>
         <p:txBody>
@@ -6340,12 +6748,12 @@
                 <a:spcPts val="0"/>
               </a:spcBef>
               <a:spcAft>
-                <a:spcPts val="600"/>
+                <a:spcPts val="700"/>
               </a:spcAft>
               <a:buNone/>
             </a:pPr>
             <a:r>
-              <a:rPr lang="en-US" sz="1100" b="1" dirty="0">
+              <a:rPr lang="en-US" sz="1250" b="1" dirty="0">
                 <a:solidFill>
                   <a:srgbClr val="BB890B"/>
                 </a:solidFill>
@@ -6353,7 +6761,7 @@
               <a:t xml:space="preserve">1  </a:t>
             </a:r>
             <a:r>
-              <a:rPr lang="en-US" sz="1100" b="1" dirty="0">
+              <a:rPr lang="en-US" sz="1250" b="1" dirty="0">
                 <a:solidFill>
                   <a:srgbClr val="213C80"/>
                 </a:solidFill>
@@ -6361,7 +6769,7 @@
               <a:t xml:space="preserve">Position  </a:t>
             </a:r>
             <a:r>
-              <a:rPr lang="en-US" sz="1100" dirty="0"/>
+              <a:rPr lang="en-US" sz="1250" dirty="0"/>
               <a:t>Supine or split legs; steep reverse Trendelenburg, then dock</a:t>
             </a:r>
           </a:p>
@@ -6371,12 +6779,12 @@
                 <a:spcPts val="0"/>
               </a:spcBef>
               <a:spcAft>
-                <a:spcPts val="600"/>
+                <a:spcPts val="700"/>
               </a:spcAft>
               <a:buNone/>
             </a:pPr>
             <a:r>
-              <a:rPr lang="en-US" sz="1100" b="1" dirty="0">
+              <a:rPr lang="en-US" sz="1250" b="1" dirty="0">
                 <a:solidFill>
                   <a:srgbClr val="BB890B"/>
                 </a:solidFill>
@@ -6384,7 +6792,7 @@
               <a:t xml:space="preserve">2  </a:t>
             </a:r>
             <a:r>
-              <a:rPr lang="en-US" sz="1100" b="1" dirty="0">
+              <a:rPr lang="en-US" sz="1250" b="1" dirty="0">
                 <a:solidFill>
                   <a:srgbClr val="213C80"/>
                 </a:solidFill>
@@ -6392,7 +6800,7 @@
               <a:t xml:space="preserve">Expose  </a:t>
             </a:r>
             <a:r>
-              <a:rPr lang="en-US" sz="1100" dirty="0"/>
+              <a:rPr lang="en-US" sz="1250" dirty="0"/>
               <a:t>Enter the lesser sac to expose the pancreas</a:t>
             </a:r>
           </a:p>
@@ -6402,12 +6810,12 @@
                 <a:spcPts val="0"/>
               </a:spcBef>
               <a:spcAft>
-                <a:spcPts val="600"/>
+                <a:spcPts val="700"/>
               </a:spcAft>
               <a:buNone/>
             </a:pPr>
             <a:r>
-              <a:rPr lang="en-US" sz="1100" b="1" dirty="0">
+              <a:rPr lang="en-US" sz="1250" b="1" dirty="0">
                 <a:solidFill>
                   <a:srgbClr val="BB890B"/>
                 </a:solidFill>
@@ -6415,7 +6823,7 @@
               <a:t xml:space="preserve">3  </a:t>
             </a:r>
             <a:r>
-              <a:rPr lang="en-US" sz="1100" b="1" dirty="0">
+              <a:rPr lang="en-US" sz="1250" b="1" dirty="0">
                 <a:solidFill>
                   <a:srgbClr val="213C80"/>
                 </a:solidFill>
@@ -6423,7 +6831,7 @@
               <a:t xml:space="preserve">Control  </a:t>
             </a:r>
             <a:r>
-              <a:rPr lang="en-US" sz="1100" dirty="0"/>
+              <a:rPr lang="en-US" sz="1250" dirty="0"/>
               <a:t>Splenic artery and splenic vein</a:t>
             </a:r>
           </a:p>
@@ -6433,12 +6841,12 @@
                 <a:spcPts val="0"/>
               </a:spcBef>
               <a:spcAft>
-                <a:spcPts val="600"/>
+                <a:spcPts val="700"/>
               </a:spcAft>
               <a:buNone/>
             </a:pPr>
             <a:r>
-              <a:rPr lang="en-US" sz="1100" b="1" dirty="0">
+              <a:rPr lang="en-US" sz="1250" b="1" dirty="0">
                 <a:solidFill>
                   <a:srgbClr val="BB890B"/>
                 </a:solidFill>
@@ -6446,7 +6854,7 @@
               <a:t xml:space="preserve">4  </a:t>
             </a:r>
             <a:r>
-              <a:rPr lang="en-US" sz="1100" b="1" dirty="0">
+              <a:rPr lang="en-US" sz="1250" b="1" dirty="0">
                 <a:solidFill>
                   <a:srgbClr val="213C80"/>
                 </a:solidFill>
@@ -6454,7 +6862,7 @@
               <a:t xml:space="preserve">Divide  </a:t>
             </a:r>
             <a:r>
-              <a:rPr lang="en-US" sz="1100" dirty="0"/>
+              <a:rPr lang="en-US" sz="1250" dirty="0"/>
               <a:t>Pancreas with a macroscopic margin</a:t>
             </a:r>
           </a:p>
@@ -6464,12 +6872,12 @@
                 <a:spcPts val="0"/>
               </a:spcBef>
               <a:spcAft>
-                <a:spcPts val="600"/>
+                <a:spcPts val="700"/>
               </a:spcAft>
               <a:buNone/>
             </a:pPr>
             <a:r>
-              <a:rPr lang="en-US" sz="1100" b="1" dirty="0">
+              <a:rPr lang="en-US" sz="1250" b="1" dirty="0">
                 <a:solidFill>
                   <a:srgbClr val="BB890B"/>
                 </a:solidFill>
@@ -6477,7 +6885,7 @@
               <a:t xml:space="preserve">5  </a:t>
             </a:r>
             <a:r>
-              <a:rPr lang="en-US" sz="1100" b="1" dirty="0">
+              <a:rPr lang="en-US" sz="1250" b="1" dirty="0">
                 <a:solidFill>
                   <a:srgbClr val="213C80"/>
                 </a:solidFill>
@@ -6485,7 +6893,7 @@
               <a:t xml:space="preserve">Resect  </a:t>
             </a:r>
             <a:r>
-              <a:rPr lang="en-US" sz="1100" dirty="0"/>
+              <a:rPr lang="en-US" sz="1250" dirty="0"/>
               <a:t>En bloc retroperitoneal dissection ± spleen</a:t>
             </a:r>
           </a:p>
@@ -6493,14 +6901,14 @@
       </p:sp>
       <p:sp>
         <p:nvSpPr>
-          <p:cNvPr id="111" name="Spleen preserving"/>
+          <p:cNvPr id="117" name="Spleen preserving"/>
           <p:cNvSpPr txBox="1"/>
           <p:nvPr/>
         </p:nvSpPr>
         <p:spPr>
           <a:xfrm>
-            <a:off x="2569464" y="10204704"/>
-            <a:ext cx="2642616" cy="621792"/>
+            <a:off x="2843784" y="13770864"/>
+            <a:ext cx="2368296" cy="749808"/>
           </a:xfrm>
           <a:prstGeom prst="roundRect">
             <a:avLst>
@@ -6530,7 +6938,7 @@
               <a:buNone/>
             </a:pPr>
             <a:r>
-              <a:rPr lang="en-US" sz="1050" b="1" dirty="0">
+              <a:rPr lang="en-US" sz="1200" b="1" dirty="0">
                 <a:solidFill>
                   <a:srgbClr val="213C80"/>
                 </a:solidFill>
@@ -6538,7 +6946,7 @@
               <a:t xml:space="preserve">Spleen-preserving options: </a:t>
             </a:r>
             <a:r>
-              <a:rPr lang="en-US" sz="1050" dirty="0"/>
+              <a:rPr lang="en-US" sz="1200" dirty="0"/>
               <a:t>splenic vessel preservation or Warshaw technique</a:t>
             </a:r>
           </a:p>
@@ -6546,853 +6954,7 @@
       </p:sp>
       <p:sp>
         <p:nvSpPr>
-          <p:cNvPr id="112" name="Section Title Platforms"/>
-          <p:cNvSpPr txBox="1"/>
-          <p:nvPr/>
-        </p:nvSpPr>
-        <p:spPr>
-          <a:xfrm>
-            <a:off x="530352" y="11100816"/>
-            <a:ext cx="4681728" cy="384048"/>
-          </a:xfrm>
-          <a:prstGeom prst="rect">
-            <a:avLst/>
-          </a:prstGeom>
-          <a:noFill/>
-          <a:ln>
-            <a:noFill/>
-          </a:ln>
-        </p:spPr>
-        <p:txBody>
-          <a:bodyPr wrap="square" lIns="0" tIns="0" rIns="0" bIns="0" anchor="ctr">
-            <a:noAutofit/>
-          </a:bodyPr>
-          <a:lstStyle/>
-          <a:p>
-            <a:pPr algn="ctr" marL="0" indent="0">
-              <a:spcBef>
-                <a:spcPts val="0"/>
-              </a:spcBef>
-              <a:spcAft>
-                <a:spcPts val="0"/>
-              </a:spcAft>
-              <a:buNone/>
-            </a:pPr>
-            <a:r>
-              <a:rPr lang="en-US" sz="1548" b="1" dirty="0">
-                <a:solidFill>
-                  <a:srgbClr val="213C80"/>
-                </a:solidFill>
-              </a:rPr>
-              <a:t>OTHER ROBOTIC PLATFORMS</a:t>
-            </a:r>
-          </a:p>
-        </p:txBody>
-      </p:sp>
-      <p:graphicFrame>
-        <p:nvGraphicFramePr>
-          <p:cNvPr id="113" name="Platforms table"/>
-          <p:cNvGraphicFramePr>
-            <a:graphicFrameLocks noGrp="1"/>
-          </p:cNvGraphicFramePr>
-          <p:nvPr/>
-        </p:nvGraphicFramePr>
-        <p:xfrm>
-          <a:off x="530352" y="11576304"/>
-          <a:ext cx="4681728" cy="2560320"/>
-        </p:xfrm>
-        <a:graphic>
-          <a:graphicData uri="http://schemas.openxmlformats.org/drawingml/2006/table">
-            <a:tbl>
-              <a:tblPr firstRow="1" bandRow="1"/>
-              <a:tblGrid>
-                <a:gridCol w="1143000"/>
-                <a:gridCol w="1417320"/>
-                <a:gridCol w="2121408"/>
-              </a:tblGrid>
-              <a:tr h="329184">
-                <a:tc>
-                  <a:txBody>
-                    <a:bodyPr/>
-                    <a:lstStyle/>
-                    <a:p>
-                      <a:pPr marL="0" indent="0">
-                        <a:spcBef>
-                          <a:spcPts val="0"/>
-                        </a:spcBef>
-                        <a:spcAft>
-                          <a:spcPts val="0"/>
-                        </a:spcAft>
-                        <a:buNone/>
-                      </a:pPr>
-                      <a:r>
-                        <a:rPr lang="en-US" sz="1050" b="1" dirty="0">
-                          <a:solidFill>
-                            <a:srgbClr val="FFFFFF"/>
-                          </a:solidFill>
-                        </a:rPr>
-                        <a:t>Platform</a:t>
-                      </a:r>
-                    </a:p>
-                  </a:txBody>
-                  <a:tcPr marL="45720" marR="45720" marT="27432" marB="27432" anchor="ctr">
-                    <a:lnL w="6350">
-                      <a:solidFill>
-                        <a:srgbClr val="D5DAE6"/>
-                      </a:solidFill>
-                    </a:lnL>
-                    <a:lnR w="6350">
-                      <a:solidFill>
-                        <a:srgbClr val="D5DAE6"/>
-                      </a:solidFill>
-                    </a:lnR>
-                    <a:lnT w="6350">
-                      <a:solidFill>
-                        <a:srgbClr val="D5DAE6"/>
-                      </a:solidFill>
-                    </a:lnT>
-                    <a:lnB w="6350">
-                      <a:solidFill>
-                        <a:srgbClr val="D5DAE6"/>
-                      </a:solidFill>
-                    </a:lnB>
-                    <a:solidFill>
-                      <a:srgbClr val="213C80"/>
-                    </a:solidFill>
-                  </a:tcPr>
-                </a:tc>
-                <a:tc>
-                  <a:txBody>
-                    <a:bodyPr/>
-                    <a:lstStyle/>
-                    <a:p>
-                      <a:pPr marL="0" indent="0">
-                        <a:spcBef>
-                          <a:spcPts val="0"/>
-                        </a:spcBef>
-                        <a:spcAft>
-                          <a:spcPts val="0"/>
-                        </a:spcAft>
-                        <a:buNone/>
-                      </a:pPr>
-                      <a:r>
-                        <a:rPr lang="en-US" sz="1050" b="1" dirty="0">
-                          <a:solidFill>
-                            <a:srgbClr val="FFFFFF"/>
-                          </a:solidFill>
-                        </a:rPr>
-                        <a:t>Distal pancreatectomy data</a:t>
-                      </a:r>
-                    </a:p>
-                  </a:txBody>
-                  <a:tcPr marL="45720" marR="45720" marT="27432" marB="27432" anchor="ctr">
-                    <a:lnL w="6350">
-                      <a:solidFill>
-                        <a:srgbClr val="D5DAE6"/>
-                      </a:solidFill>
-                    </a:lnL>
-                    <a:lnR w="6350">
-                      <a:solidFill>
-                        <a:srgbClr val="D5DAE6"/>
-                      </a:solidFill>
-                    </a:lnR>
-                    <a:lnT w="6350">
-                      <a:solidFill>
-                        <a:srgbClr val="D5DAE6"/>
-                      </a:solidFill>
-                    </a:lnT>
-                    <a:lnB w="6350">
-                      <a:solidFill>
-                        <a:srgbClr val="D5DAE6"/>
-                      </a:solidFill>
-                    </a:lnB>
-                    <a:solidFill>
-                      <a:srgbClr val="213C80"/>
-                    </a:solidFill>
-                  </a:tcPr>
-                </a:tc>
-                <a:tc>
-                  <a:txBody>
-                    <a:bodyPr/>
-                    <a:lstStyle/>
-                    <a:p>
-                      <a:pPr marL="0" indent="0">
-                        <a:spcBef>
-                          <a:spcPts val="0"/>
-                        </a:spcBef>
-                        <a:spcAft>
-                          <a:spcPts val="0"/>
-                        </a:spcAft>
-                        <a:buNone/>
-                      </a:pPr>
-                      <a:r>
-                        <a:rPr lang="en-US" sz="1050" b="1" dirty="0">
-                          <a:solidFill>
-                            <a:srgbClr val="FFFFFF"/>
-                          </a:solidFill>
-                        </a:rPr>
-                        <a:t>Notes</a:t>
-                      </a:r>
-                    </a:p>
-                  </a:txBody>
-                  <a:tcPr marL="45720" marR="45720" marT="27432" marB="27432" anchor="ctr">
-                    <a:lnL w="6350">
-                      <a:solidFill>
-                        <a:srgbClr val="D5DAE6"/>
-                      </a:solidFill>
-                    </a:lnL>
-                    <a:lnR w="6350">
-                      <a:solidFill>
-                        <a:srgbClr val="D5DAE6"/>
-                      </a:solidFill>
-                    </a:lnR>
-                    <a:lnT w="6350">
-                      <a:solidFill>
-                        <a:srgbClr val="D5DAE6"/>
-                      </a:solidFill>
-                    </a:lnT>
-                    <a:lnB w="6350">
-                      <a:solidFill>
-                        <a:srgbClr val="D5DAE6"/>
-                      </a:solidFill>
-                    </a:lnB>
-                    <a:solidFill>
-                      <a:srgbClr val="213C80"/>
-                    </a:solidFill>
-                  </a:tcPr>
-                </a:tc>
-              </a:tr>
-              <a:tr h="457200">
-                <a:tc>
-                  <a:txBody>
-                    <a:bodyPr/>
-                    <a:lstStyle/>
-                    <a:p>
-                      <a:pPr marL="0" indent="0">
-                        <a:spcBef>
-                          <a:spcPts val="0"/>
-                        </a:spcBef>
-                        <a:spcAft>
-                          <a:spcPts val="0"/>
-                        </a:spcAft>
-                        <a:buNone/>
-                      </a:pPr>
-                      <a:r>
-                        <a:rPr lang="en-US" sz="1000" b="1" dirty="0"/>
-                        <a:t>da Vinci</a:t>
-                      </a:r>
-                    </a:p>
-                    <a:p>
-                      <a:pPr marL="0" indent="0">
-                        <a:spcBef>
-                          <a:spcPts val="0"/>
-                        </a:spcBef>
-                        <a:spcAft>
-                          <a:spcPts val="0"/>
-                        </a:spcAft>
-                        <a:buNone/>
-                      </a:pPr>
-                      <a:r>
-                        <a:rPr lang="en-US" sz="1000" dirty="0">
-                          <a:solidFill>
-                            <a:srgbClr val="5B6170"/>
-                          </a:solidFill>
-                        </a:rPr>
-                        <a:t>Intuitive</a:t>
-                      </a:r>
-                    </a:p>
-                  </a:txBody>
-                  <a:tcPr marL="45720" marR="45720" marT="27432" marB="27432" anchor="ctr">
-                    <a:lnL w="6350">
-                      <a:solidFill>
-                        <a:srgbClr val="D5DAE6"/>
-                      </a:solidFill>
-                    </a:lnL>
-                    <a:lnR w="6350">
-                      <a:solidFill>
-                        <a:srgbClr val="D5DAE6"/>
-                      </a:solidFill>
-                    </a:lnR>
-                    <a:lnT w="6350">
-                      <a:solidFill>
-                        <a:srgbClr val="D5DAE6"/>
-                      </a:solidFill>
-                    </a:lnT>
-                    <a:lnB w="6350">
-                      <a:solidFill>
-                        <a:srgbClr val="D5DAE6"/>
-                      </a:solidFill>
-                    </a:lnB>
-                    <a:noFill/>
-                  </a:tcPr>
-                </a:tc>
-                <a:tc>
-                  <a:txBody>
-                    <a:bodyPr/>
-                    <a:lstStyle/>
-                    <a:p>
-                      <a:pPr marL="0" indent="0">
-                        <a:spcBef>
-                          <a:spcPts val="0"/>
-                        </a:spcBef>
-                        <a:spcAft>
-                          <a:spcPts val="0"/>
-                        </a:spcAft>
-                        <a:buNone/>
-                      </a:pPr>
-                      <a:r>
-                        <a:rPr lang="en-US" sz="1000" dirty="0"/>
-                        <a:t>Almost all published RDP</a:t>
-                      </a:r>
-                    </a:p>
-                  </a:txBody>
-                  <a:tcPr marL="45720" marR="45720" marT="27432" marB="27432" anchor="ctr">
-                    <a:lnL w="6350">
-                      <a:solidFill>
-                        <a:srgbClr val="D5DAE6"/>
-                      </a:solidFill>
-                    </a:lnL>
-                    <a:lnR w="6350">
-                      <a:solidFill>
-                        <a:srgbClr val="D5DAE6"/>
-                      </a:solidFill>
-                    </a:lnR>
-                    <a:lnT w="6350">
-                      <a:solidFill>
-                        <a:srgbClr val="D5DAE6"/>
-                      </a:solidFill>
-                    </a:lnT>
-                    <a:lnB w="6350">
-                      <a:solidFill>
-                        <a:srgbClr val="D5DAE6"/>
-                      </a:solidFill>
-                    </a:lnB>
-                    <a:noFill/>
-                  </a:tcPr>
-                </a:tc>
-                <a:tc>
-                  <a:txBody>
-                    <a:bodyPr/>
-                    <a:lstStyle/>
-                    <a:p>
-                      <a:pPr marL="0" indent="0">
-                        <a:spcBef>
-                          <a:spcPts val="0"/>
-                        </a:spcBef>
-                        <a:spcAft>
-                          <a:spcPts val="0"/>
-                        </a:spcAft>
-                        <a:buNone/>
-                      </a:pPr>
-                      <a:r>
-                        <a:rPr lang="en-US" sz="1000" dirty="0"/>
-                        <a:t>Reference platform</a:t>
-                      </a:r>
-                    </a:p>
-                  </a:txBody>
-                  <a:tcPr marL="45720" marR="45720" marT="27432" marB="27432" anchor="ctr">
-                    <a:lnL w="6350">
-                      <a:solidFill>
-                        <a:srgbClr val="D5DAE6"/>
-                      </a:solidFill>
-                    </a:lnL>
-                    <a:lnR w="6350">
-                      <a:solidFill>
-                        <a:srgbClr val="D5DAE6"/>
-                      </a:solidFill>
-                    </a:lnR>
-                    <a:lnT w="6350">
-                      <a:solidFill>
-                        <a:srgbClr val="D5DAE6"/>
-                      </a:solidFill>
-                    </a:lnT>
-                    <a:lnB w="6350">
-                      <a:solidFill>
-                        <a:srgbClr val="D5DAE6"/>
-                      </a:solidFill>
-                    </a:lnB>
-                    <a:noFill/>
-                  </a:tcPr>
-                </a:tc>
-              </a:tr>
-              <a:tr h="457200">
-                <a:tc>
-                  <a:txBody>
-                    <a:bodyPr/>
-                    <a:lstStyle/>
-                    <a:p>
-                      <a:pPr marL="0" indent="0">
-                        <a:spcBef>
-                          <a:spcPts val="0"/>
-                        </a:spcBef>
-                        <a:spcAft>
-                          <a:spcPts val="0"/>
-                        </a:spcAft>
-                        <a:buNone/>
-                      </a:pPr>
-                      <a:r>
-                        <a:rPr lang="en-US" sz="1000" b="1" dirty="0"/>
-                        <a:t>Hugo</a:t>
-                      </a:r>
-                    </a:p>
-                    <a:p>
-                      <a:pPr marL="0" indent="0">
-                        <a:spcBef>
-                          <a:spcPts val="0"/>
-                        </a:spcBef>
-                        <a:spcAft>
-                          <a:spcPts val="0"/>
-                        </a:spcAft>
-                        <a:buNone/>
-                      </a:pPr>
-                      <a:r>
-                        <a:rPr lang="en-US" sz="1000" dirty="0">
-                          <a:solidFill>
-                            <a:srgbClr val="5B6170"/>
-                          </a:solidFill>
-                        </a:rPr>
-                        <a:t>Medtronic</a:t>
-                      </a:r>
-                    </a:p>
-                  </a:txBody>
-                  <a:tcPr marL="45720" marR="45720" marT="27432" marB="27432" anchor="ctr">
-                    <a:lnL w="6350">
-                      <a:solidFill>
-                        <a:srgbClr val="D5DAE6"/>
-                      </a:solidFill>
-                    </a:lnL>
-                    <a:lnR w="6350">
-                      <a:solidFill>
-                        <a:srgbClr val="D5DAE6"/>
-                      </a:solidFill>
-                    </a:lnR>
-                    <a:lnT w="6350">
-                      <a:solidFill>
-                        <a:srgbClr val="D5DAE6"/>
-                      </a:solidFill>
-                    </a:lnT>
-                    <a:lnB w="6350">
-                      <a:solidFill>
-                        <a:srgbClr val="D5DAE6"/>
-                      </a:solidFill>
-                    </a:lnB>
-                    <a:solidFill>
-                      <a:srgbClr val="EEF1F8"/>
-                    </a:solidFill>
-                  </a:tcPr>
-                </a:tc>
-                <a:tc>
-                  <a:txBody>
-                    <a:bodyPr/>
-                    <a:lstStyle/>
-                    <a:p>
-                      <a:pPr marL="0" indent="0">
-                        <a:spcBef>
-                          <a:spcPts val="0"/>
-                        </a:spcBef>
-                        <a:spcAft>
-                          <a:spcPts val="0"/>
-                        </a:spcAft>
-                        <a:buNone/>
-                      </a:pPr>
-                      <a:r>
-                        <a:rPr lang="en-US" sz="1000" dirty="0"/>
-                        <a:t>No cases reported</a:t>
-                      </a:r>
-                    </a:p>
-                  </a:txBody>
-                  <a:tcPr marL="45720" marR="45720" marT="27432" marB="27432" anchor="ctr">
-                    <a:lnL w="6350">
-                      <a:solidFill>
-                        <a:srgbClr val="D5DAE6"/>
-                      </a:solidFill>
-                    </a:lnL>
-                    <a:lnR w="6350">
-                      <a:solidFill>
-                        <a:srgbClr val="D5DAE6"/>
-                      </a:solidFill>
-                    </a:lnR>
-                    <a:lnT w="6350">
-                      <a:solidFill>
-                        <a:srgbClr val="D5DAE6"/>
-                      </a:solidFill>
-                    </a:lnT>
-                    <a:lnB w="6350">
-                      <a:solidFill>
-                        <a:srgbClr val="D5DAE6"/>
-                      </a:solidFill>
-                    </a:lnB>
-                    <a:solidFill>
-                      <a:srgbClr val="EEF1F8"/>
-                    </a:solidFill>
-                  </a:tcPr>
-                </a:tc>
-                <a:tc>
-                  <a:txBody>
-                    <a:bodyPr/>
-                    <a:lstStyle/>
-                    <a:p>
-                      <a:pPr marL="0" indent="0">
-                        <a:spcBef>
-                          <a:spcPts val="0"/>
-                        </a:spcBef>
-                        <a:spcAft>
-                          <a:spcPts val="0"/>
-                        </a:spcAft>
-                        <a:buNone/>
-                      </a:pPr>
-                      <a:r>
-                        <a:rPr lang="en-US" sz="1000" dirty="0"/>
-                        <a:t>First generation</a:t>
-                      </a:r>
-                    </a:p>
-                  </a:txBody>
-                  <a:tcPr marL="45720" marR="45720" marT="27432" marB="27432" anchor="ctr">
-                    <a:lnL w="6350">
-                      <a:solidFill>
-                        <a:srgbClr val="D5DAE6"/>
-                      </a:solidFill>
-                    </a:lnL>
-                    <a:lnR w="6350">
-                      <a:solidFill>
-                        <a:srgbClr val="D5DAE6"/>
-                      </a:solidFill>
-                    </a:lnR>
-                    <a:lnT w="6350">
-                      <a:solidFill>
-                        <a:srgbClr val="D5DAE6"/>
-                      </a:solidFill>
-                    </a:lnT>
-                    <a:lnB w="6350">
-                      <a:solidFill>
-                        <a:srgbClr val="D5DAE6"/>
-                      </a:solidFill>
-                    </a:lnB>
-                    <a:solidFill>
-                      <a:srgbClr val="EEF1F8"/>
-                    </a:solidFill>
-                  </a:tcPr>
-                </a:tc>
-              </a:tr>
-              <a:tr h="658368">
-                <a:tc>
-                  <a:txBody>
-                    <a:bodyPr/>
-                    <a:lstStyle/>
-                    <a:p>
-                      <a:pPr marL="0" indent="0">
-                        <a:spcBef>
-                          <a:spcPts val="0"/>
-                        </a:spcBef>
-                        <a:spcAft>
-                          <a:spcPts val="0"/>
-                        </a:spcAft>
-                        <a:buNone/>
-                      </a:pPr>
-                      <a:r>
-                        <a:rPr lang="en-US" sz="1000" b="1" dirty="0"/>
-                        <a:t>Versius</a:t>
-                      </a:r>
-                    </a:p>
-                    <a:p>
-                      <a:pPr marL="0" indent="0">
-                        <a:spcBef>
-                          <a:spcPts val="0"/>
-                        </a:spcBef>
-                        <a:spcAft>
-                          <a:spcPts val="0"/>
-                        </a:spcAft>
-                        <a:buNone/>
-                      </a:pPr>
-                      <a:r>
-                        <a:rPr lang="en-US" sz="1000" dirty="0">
-                          <a:solidFill>
-                            <a:srgbClr val="5B6170"/>
-                          </a:solidFill>
-                        </a:rPr>
-                        <a:t>CMR</a:t>
-                      </a:r>
-                    </a:p>
-                  </a:txBody>
-                  <a:tcPr marL="45720" marR="45720" marT="27432" marB="27432" anchor="ctr">
-                    <a:lnL w="6350">
-                      <a:solidFill>
-                        <a:srgbClr val="D5DAE6"/>
-                      </a:solidFill>
-                    </a:lnL>
-                    <a:lnR w="6350">
-                      <a:solidFill>
-                        <a:srgbClr val="D5DAE6"/>
-                      </a:solidFill>
-                    </a:lnR>
-                    <a:lnT w="6350">
-                      <a:solidFill>
-                        <a:srgbClr val="D5DAE6"/>
-                      </a:solidFill>
-                    </a:lnT>
-                    <a:lnB w="6350">
-                      <a:solidFill>
-                        <a:srgbClr val="D5DAE6"/>
-                      </a:solidFill>
-                    </a:lnB>
-                    <a:noFill/>
-                  </a:tcPr>
-                </a:tc>
-                <a:tc>
-                  <a:txBody>
-                    <a:bodyPr/>
-                    <a:lstStyle/>
-                    <a:p>
-                      <a:pPr marL="0" indent="0">
-                        <a:spcBef>
-                          <a:spcPts val="0"/>
-                        </a:spcBef>
-                        <a:spcAft>
-                          <a:spcPts val="0"/>
-                        </a:spcAft>
-                        <a:buNone/>
-                      </a:pPr>
-                      <a:r>
-                        <a:rPr lang="en-US" sz="1000" dirty="0"/>
-                        <a:t>9-case series</a:t>
-                      </a:r>
-                    </a:p>
-                  </a:txBody>
-                  <a:tcPr marL="45720" marR="45720" marT="27432" marB="27432" anchor="ctr">
-                    <a:lnL w="6350">
-                      <a:solidFill>
-                        <a:srgbClr val="D5DAE6"/>
-                      </a:solidFill>
-                    </a:lnL>
-                    <a:lnR w="6350">
-                      <a:solidFill>
-                        <a:srgbClr val="D5DAE6"/>
-                      </a:solidFill>
-                    </a:lnR>
-                    <a:lnT w="6350">
-                      <a:solidFill>
-                        <a:srgbClr val="D5DAE6"/>
-                      </a:solidFill>
-                    </a:lnT>
-                    <a:lnB w="6350">
-                      <a:solidFill>
-                        <a:srgbClr val="D5DAE6"/>
-                      </a:solidFill>
-                    </a:lnB>
-                    <a:noFill/>
-                  </a:tcPr>
-                </a:tc>
-                <a:tc>
-                  <a:txBody>
-                    <a:bodyPr/>
-                    <a:lstStyle/>
-                    <a:p>
-                      <a:pPr marL="0" indent="0">
-                        <a:spcBef>
-                          <a:spcPts val="0"/>
-                        </a:spcBef>
-                        <a:spcAft>
-                          <a:spcPts val="0"/>
-                        </a:spcAft>
-                        <a:buNone/>
-                      </a:pPr>
-                      <a:r>
-                        <a:rPr lang="en-US" sz="1000" dirty="0"/>
-                        <a:t>Mean OT 185 min, LOS 7 d; slower set-up, no integrated energy device</a:t>
-                      </a:r>
-                    </a:p>
-                  </a:txBody>
-                  <a:tcPr marL="45720" marR="45720" marT="27432" marB="27432" anchor="ctr">
-                    <a:lnL w="6350">
-                      <a:solidFill>
-                        <a:srgbClr val="D5DAE6"/>
-                      </a:solidFill>
-                    </a:lnL>
-                    <a:lnR w="6350">
-                      <a:solidFill>
-                        <a:srgbClr val="D5DAE6"/>
-                      </a:solidFill>
-                    </a:lnR>
-                    <a:lnT w="6350">
-                      <a:solidFill>
-                        <a:srgbClr val="D5DAE6"/>
-                      </a:solidFill>
-                    </a:lnT>
-                    <a:lnB w="6350">
-                      <a:solidFill>
-                        <a:srgbClr val="D5DAE6"/>
-                      </a:solidFill>
-                    </a:lnB>
-                    <a:noFill/>
-                  </a:tcPr>
-                </a:tc>
-              </a:tr>
-              <a:tr h="658368">
-                <a:tc>
-                  <a:txBody>
-                    <a:bodyPr/>
-                    <a:lstStyle/>
-                    <a:p>
-                      <a:pPr marL="0" indent="0">
-                        <a:spcBef>
-                          <a:spcPts val="0"/>
-                        </a:spcBef>
-                        <a:spcAft>
-                          <a:spcPts val="0"/>
-                        </a:spcAft>
-                        <a:buNone/>
-                      </a:pPr>
-                      <a:r>
-                        <a:rPr lang="en-US" sz="1000" b="1" dirty="0"/>
-                        <a:t>hinotori™</a:t>
-                      </a:r>
-                    </a:p>
-                    <a:p>
-                      <a:pPr marL="0" indent="0">
-                        <a:spcBef>
-                          <a:spcPts val="0"/>
-                        </a:spcBef>
-                        <a:spcAft>
-                          <a:spcPts val="0"/>
-                        </a:spcAft>
-                        <a:buNone/>
-                      </a:pPr>
-                      <a:r>
-                        <a:rPr lang="en-US" sz="1000" dirty="0">
-                          <a:solidFill>
-                            <a:srgbClr val="5B6170"/>
-                          </a:solidFill>
-                        </a:rPr>
-                        <a:t>Medicaroid</a:t>
-                      </a:r>
-                    </a:p>
-                  </a:txBody>
-                  <a:tcPr marL="45720" marR="45720" marT="27432" marB="27432" anchor="ctr">
-                    <a:lnL w="6350">
-                      <a:solidFill>
-                        <a:srgbClr val="D5DAE6"/>
-                      </a:solidFill>
-                    </a:lnL>
-                    <a:lnR w="6350">
-                      <a:solidFill>
-                        <a:srgbClr val="D5DAE6"/>
-                      </a:solidFill>
-                    </a:lnR>
-                    <a:lnT w="6350">
-                      <a:solidFill>
-                        <a:srgbClr val="D5DAE6"/>
-                      </a:solidFill>
-                    </a:lnT>
-                    <a:lnB w="6350">
-                      <a:solidFill>
-                        <a:srgbClr val="D5DAE6"/>
-                      </a:solidFill>
-                    </a:lnB>
-                    <a:solidFill>
-                      <a:srgbClr val="EEF1F8"/>
-                    </a:solidFill>
-                  </a:tcPr>
-                </a:tc>
-                <a:tc>
-                  <a:txBody>
-                    <a:bodyPr/>
-                    <a:lstStyle/>
-                    <a:p>
-                      <a:pPr marL="0" indent="0">
-                        <a:spcBef>
-                          <a:spcPts val="0"/>
-                        </a:spcBef>
-                        <a:spcAft>
-                          <a:spcPts val="0"/>
-                        </a:spcAft>
-                        <a:buNone/>
-                      </a:pPr>
-                      <a:r>
-                        <a:rPr lang="en-US" sz="1000" dirty="0"/>
-                        <a:t>Single case report</a:t>
-                      </a:r>
-                    </a:p>
-                  </a:txBody>
-                  <a:tcPr marL="45720" marR="45720" marT="27432" marB="27432" anchor="ctr">
-                    <a:lnL w="6350">
-                      <a:solidFill>
-                        <a:srgbClr val="D5DAE6"/>
-                      </a:solidFill>
-                    </a:lnL>
-                    <a:lnR w="6350">
-                      <a:solidFill>
-                        <a:srgbClr val="D5DAE6"/>
-                      </a:solidFill>
-                    </a:lnR>
-                    <a:lnT w="6350">
-                      <a:solidFill>
-                        <a:srgbClr val="D5DAE6"/>
-                      </a:solidFill>
-                    </a:lnT>
-                    <a:lnB w="6350">
-                      <a:solidFill>
-                        <a:srgbClr val="D5DAE6"/>
-                      </a:solidFill>
-                    </a:lnB>
-                    <a:solidFill>
-                      <a:srgbClr val="EEF1F8"/>
-                    </a:solidFill>
-                  </a:tcPr>
-                </a:tc>
-                <a:tc>
-                  <a:txBody>
-                    <a:bodyPr/>
-                    <a:lstStyle/>
-                    <a:p>
-                      <a:pPr marL="0" indent="0">
-                        <a:spcBef>
-                          <a:spcPts val="0"/>
-                        </a:spcBef>
-                        <a:spcAft>
-                          <a:spcPts val="0"/>
-                        </a:spcAft>
-                        <a:buNone/>
-                      </a:pPr>
-                      <a:r>
-                        <a:rPr lang="en-US" sz="1000" dirty="0"/>
-                        <a:t>Docking-free, flexible arms; longer set-up, no vessel sealer</a:t>
-                      </a:r>
-                    </a:p>
-                  </a:txBody>
-                  <a:tcPr marL="45720" marR="45720" marT="27432" marB="27432" anchor="ctr">
-                    <a:lnL w="6350">
-                      <a:solidFill>
-                        <a:srgbClr val="D5DAE6"/>
-                      </a:solidFill>
-                    </a:lnL>
-                    <a:lnR w="6350">
-                      <a:solidFill>
-                        <a:srgbClr val="D5DAE6"/>
-                      </a:solidFill>
-                    </a:lnR>
-                    <a:lnT w="6350">
-                      <a:solidFill>
-                        <a:srgbClr val="D5DAE6"/>
-                      </a:solidFill>
-                    </a:lnT>
-                    <a:lnB w="6350">
-                      <a:solidFill>
-                        <a:srgbClr val="D5DAE6"/>
-                      </a:solidFill>
-                    </a:lnB>
-                    <a:solidFill>
-                      <a:srgbClr val="EEF1F8"/>
-                    </a:solidFill>
-                  </a:tcPr>
-                </a:tc>
-              </a:tr>
-            </a:tbl>
-          </a:graphicData>
-        </a:graphic>
-      </p:graphicFrame>
-      <p:sp>
-        <p:nvSpPr>
-          <p:cNvPr id="114" name="Section Title 40"/>
+          <p:cNvPr id="118" name="Section Title 40"/>
           <p:cNvSpPr>
             <a:spLocks noGrp="1"/>
           </p:cNvSpPr>
@@ -7402,7 +6964,7 @@
         </p:nvSpPr>
         <p:spPr>
           <a:xfrm>
-            <a:off x="530352" y="14520672"/>
+            <a:off x="530352" y="14886432"/>
             <a:ext cx="4681728" cy="384048"/>
           </a:xfrm>
         </p:spPr>
@@ -7430,13 +6992,13 @@
       </p:sp>
       <p:sp>
         <p:nvSpPr>
-          <p:cNvPr id="115" name="Challenge icon"/>
+          <p:cNvPr id="119" name="Challenge icon"/>
           <p:cNvSpPr txBox="1"/>
           <p:nvPr/>
         </p:nvSpPr>
         <p:spPr>
           <a:xfrm>
-            <a:off x="530352" y="15041880"/>
+            <a:off x="530352" y="15407640"/>
             <a:ext cx="384048" cy="384048"/>
           </a:xfrm>
           <a:prstGeom prst="ellipse">
@@ -7477,14 +7039,14 @@
       </p:sp>
       <p:sp>
         <p:nvSpPr>
-          <p:cNvPr id="116" name="Challenge Operative time"/>
+          <p:cNvPr id="120" name="Challenge Operative time"/>
           <p:cNvSpPr txBox="1"/>
           <p:nvPr/>
         </p:nvSpPr>
         <p:spPr>
           <a:xfrm>
-            <a:off x="1060704" y="14996160"/>
-            <a:ext cx="4151376" cy="868680"/>
+            <a:off x="1060704" y="15361920"/>
+            <a:ext cx="4151376" cy="960120"/>
           </a:xfrm>
           <a:prstGeom prst="rect">
             <a:avLst/>
@@ -7510,7 +7072,7 @@
               <a:buNone/>
             </a:pPr>
             <a:r>
-              <a:rPr lang="en-US" sz="1200" b="1" dirty="0">
+              <a:rPr lang="en-US" sz="1350" b="1" dirty="0">
                 <a:solidFill>
                   <a:srgbClr val="213C80"/>
                 </a:solidFill>
@@ -7529,7 +7091,7 @@
               <a:buNone/>
             </a:pPr>
             <a:r>
-              <a:rPr lang="en-US" sz="1100" dirty="0"/>
+              <a:rPr lang="en-US" sz="1250" dirty="0"/>
               <a:t>≈30 min longer than LDP in meta-analysis, largely robot docking; shortens along the learning curve.</a:t>
             </a:r>
           </a:p>
@@ -7537,13 +7099,13 @@
       </p:sp>
       <p:sp>
         <p:nvSpPr>
-          <p:cNvPr id="117" name="Challenge icon"/>
+          <p:cNvPr id="121" name="Challenge icon"/>
           <p:cNvSpPr txBox="1"/>
           <p:nvPr/>
         </p:nvSpPr>
         <p:spPr>
           <a:xfrm>
-            <a:off x="530352" y="16002000"/>
+            <a:off x="530352" y="16431768"/>
             <a:ext cx="384048" cy="384048"/>
           </a:xfrm>
           <a:prstGeom prst="ellipse">
@@ -7584,14 +7146,14 @@
       </p:sp>
       <p:sp>
         <p:nvSpPr>
-          <p:cNvPr id="118" name="Challenge Team &amp; training"/>
+          <p:cNvPr id="122" name="Challenge Team &amp; training"/>
           <p:cNvSpPr txBox="1"/>
           <p:nvPr/>
         </p:nvSpPr>
         <p:spPr>
           <a:xfrm>
-            <a:off x="1060704" y="15956280"/>
-            <a:ext cx="4151376" cy="868680"/>
+            <a:off x="1060704" y="16386048"/>
+            <a:ext cx="4151376" cy="960120"/>
           </a:xfrm>
           <a:prstGeom prst="rect">
             <a:avLst/>
@@ -7617,7 +7179,7 @@
               <a:buNone/>
             </a:pPr>
             <a:r>
-              <a:rPr lang="en-US" sz="1200" b="1" dirty="0">
+              <a:rPr lang="en-US" sz="1350" b="1" dirty="0">
                 <a:solidFill>
                   <a:srgbClr val="213C80"/>
                 </a:solidFill>
@@ -7636,7 +7198,7 @@
               <a:buNone/>
             </a:pPr>
             <a:r>
-              <a:rPr lang="en-US" sz="1100" dirty="0"/>
+              <a:rPr lang="en-US" sz="1250" dirty="0"/>
               <a:t>Needs a console surgeon, skilled bedside assistant and robot-trained scrub nurse; few training centres.</a:t>
             </a:r>
           </a:p>
@@ -7644,13 +7206,13 @@
       </p:sp>
       <p:sp>
         <p:nvSpPr>
-          <p:cNvPr id="119" name="Challenge icon"/>
+          <p:cNvPr id="123" name="Challenge icon"/>
           <p:cNvSpPr txBox="1"/>
           <p:nvPr/>
         </p:nvSpPr>
         <p:spPr>
           <a:xfrm>
-            <a:off x="530352" y="16962120"/>
+            <a:off x="530352" y="17455896"/>
             <a:ext cx="384048" cy="384048"/>
           </a:xfrm>
           <a:prstGeom prst="ellipse">
@@ -7691,14 +7253,14 @@
       </p:sp>
       <p:sp>
         <p:nvSpPr>
-          <p:cNvPr id="120" name="Challenge Cost &amp; access"/>
+          <p:cNvPr id="124" name="Challenge Cost &amp; access"/>
           <p:cNvSpPr txBox="1"/>
           <p:nvPr/>
         </p:nvSpPr>
         <p:spPr>
           <a:xfrm>
-            <a:off x="1060704" y="16916400"/>
-            <a:ext cx="4151376" cy="868680"/>
+            <a:off x="1060704" y="17410176"/>
+            <a:ext cx="4151376" cy="960120"/>
           </a:xfrm>
           <a:prstGeom prst="rect">
             <a:avLst/>
@@ -7724,7 +7286,7 @@
               <a:buNone/>
             </a:pPr>
             <a:r>
-              <a:rPr lang="en-US" sz="1200" b="1" dirty="0">
+              <a:rPr lang="en-US" sz="1350" b="1" dirty="0">
                 <a:solidFill>
                   <a:srgbClr val="213C80"/>
                 </a:solidFill>
@@ -7743,7 +7305,7 @@
               <a:buNone/>
             </a:pPr>
             <a:r>
-              <a:rPr lang="en-US" sz="1100" dirty="0"/>
+              <a:rPr lang="en-US" sz="1250" dirty="0"/>
               <a:t>High upfront cost; robots concentrated in advanced economies, creating inequity of access.</a:t>
             </a:r>
           </a:p>
@@ -7751,362 +7313,7 @@
       </p:sp>
       <p:sp>
         <p:nvSpPr>
-          <p:cNvPr id="121" name="Section Title Advantages"/>
-          <p:cNvSpPr txBox="1"/>
-          <p:nvPr/>
-        </p:nvSpPr>
-        <p:spPr>
-          <a:xfrm>
-            <a:off x="5952744" y="4224528"/>
-            <a:ext cx="4681728" cy="384048"/>
-          </a:xfrm>
-          <a:prstGeom prst="rect">
-            <a:avLst/>
-          </a:prstGeom>
-          <a:noFill/>
-          <a:ln>
-            <a:noFill/>
-          </a:ln>
-        </p:spPr>
-        <p:txBody>
-          <a:bodyPr wrap="square" lIns="0" tIns="0" rIns="0" bIns="0" anchor="ctr">
-            <a:noAutofit/>
-          </a:bodyPr>
-          <a:lstStyle/>
-          <a:p>
-            <a:pPr algn="ctr" marL="0" indent="0">
-              <a:spcBef>
-                <a:spcPts val="0"/>
-              </a:spcBef>
-              <a:spcAft>
-                <a:spcPts val="0"/>
-              </a:spcAft>
-              <a:buNone/>
-            </a:pPr>
-            <a:r>
-              <a:rPr lang="en-US" sz="1548" b="1" dirty="0">
-                <a:solidFill>
-                  <a:srgbClr val="213C80"/>
-                </a:solidFill>
-              </a:rPr>
-              <a:t>WHY ROBOTIC?</a:t>
-            </a:r>
-          </a:p>
-        </p:txBody>
-      </p:sp>
-      <p:sp>
-        <p:nvSpPr>
-          <p:cNvPr id="122" name="Advantage 3D"/>
-          <p:cNvSpPr txBox="1"/>
-          <p:nvPr/>
-        </p:nvSpPr>
-        <p:spPr>
-          <a:xfrm>
-            <a:off x="5952744" y="4700016"/>
-            <a:ext cx="1067562" cy="868680"/>
-          </a:xfrm>
-          <a:prstGeom prst="roundRect">
-            <a:avLst>
-              <a:gd name="adj" fmla="val 14000"/>
-            </a:avLst>
-          </a:prstGeom>
-          <a:solidFill>
-            <a:srgbClr val="EEF1F8"/>
-          </a:solidFill>
-          <a:ln>
-            <a:noFill/>
-          </a:ln>
-        </p:spPr>
-        <p:txBody>
-          <a:bodyPr wrap="square" lIns="36576" tIns="36576" rIns="36576" bIns="36576" anchor="ctr">
-            <a:noAutofit/>
-          </a:bodyPr>
-          <a:lstStyle/>
-          <a:p>
-            <a:pPr algn="ctr" marL="0" indent="0">
-              <a:spcBef>
-                <a:spcPts val="0"/>
-              </a:spcBef>
-              <a:spcAft>
-                <a:spcPts val="100"/>
-              </a:spcAft>
-              <a:buNone/>
-            </a:pPr>
-            <a:r>
-              <a:rPr lang="en-US" sz="1400" b="1" dirty="0">
-                <a:solidFill>
-                  <a:srgbClr val="213C80"/>
-                </a:solidFill>
-              </a:rPr>
-              <a:t>3D</a:t>
-            </a:r>
-          </a:p>
-          <a:p>
-            <a:pPr algn="ctr" marL="0" indent="0">
-              <a:spcBef>
-                <a:spcPts val="0"/>
-              </a:spcBef>
-              <a:spcAft>
-                <a:spcPts val="0"/>
-              </a:spcAft>
-              <a:buNone/>
-            </a:pPr>
-            <a:r>
-              <a:rPr lang="en-US" sz="1000" dirty="0">
-                <a:solidFill>
-                  <a:srgbClr val="5B6170"/>
-                </a:solidFill>
-              </a:rPr>
-              <a:t>magnified</a:t>
-            </a:r>
-          </a:p>
-          <a:p>
-            <a:pPr algn="ctr" marL="0" indent="0">
-              <a:spcBef>
-                <a:spcPts val="0"/>
-              </a:spcBef>
-              <a:spcAft>
-                <a:spcPts val="0"/>
-              </a:spcAft>
-              <a:buNone/>
-            </a:pPr>
-            <a:r>
-              <a:rPr lang="en-US" sz="1000" dirty="0">
-                <a:solidFill>
-                  <a:srgbClr val="5B6170"/>
-                </a:solidFill>
-              </a:rPr>
-              <a:t>visualisation</a:t>
-            </a:r>
-          </a:p>
-        </p:txBody>
-      </p:sp>
-      <p:sp>
-        <p:nvSpPr>
-          <p:cNvPr id="123" name="Advantage Tremor"/>
-          <p:cNvSpPr txBox="1"/>
-          <p:nvPr/>
-        </p:nvSpPr>
-        <p:spPr>
-          <a:xfrm>
-            <a:off x="7157466" y="4700016"/>
-            <a:ext cx="1067562" cy="868680"/>
-          </a:xfrm>
-          <a:prstGeom prst="roundRect">
-            <a:avLst>
-              <a:gd name="adj" fmla="val 14000"/>
-            </a:avLst>
-          </a:prstGeom>
-          <a:solidFill>
-            <a:srgbClr val="EEF1F8"/>
-          </a:solidFill>
-          <a:ln>
-            <a:noFill/>
-          </a:ln>
-        </p:spPr>
-        <p:txBody>
-          <a:bodyPr wrap="square" lIns="36576" tIns="36576" rIns="36576" bIns="36576" anchor="ctr">
-            <a:noAutofit/>
-          </a:bodyPr>
-          <a:lstStyle/>
-          <a:p>
-            <a:pPr algn="ctr" marL="0" indent="0">
-              <a:spcBef>
-                <a:spcPts val="0"/>
-              </a:spcBef>
-              <a:spcAft>
-                <a:spcPts val="100"/>
-              </a:spcAft>
-              <a:buNone/>
-            </a:pPr>
-            <a:r>
-              <a:rPr lang="en-US" sz="1400" b="1" dirty="0">
-                <a:solidFill>
-                  <a:srgbClr val="213C80"/>
-                </a:solidFill>
-              </a:rPr>
-              <a:t>Tremor</a:t>
-            </a:r>
-          </a:p>
-          <a:p>
-            <a:pPr algn="ctr" marL="0" indent="0">
-              <a:spcBef>
-                <a:spcPts val="0"/>
-              </a:spcBef>
-              <a:spcAft>
-                <a:spcPts val="0"/>
-              </a:spcAft>
-              <a:buNone/>
-            </a:pPr>
-            <a:r>
-              <a:rPr lang="en-US" sz="1000" dirty="0">
-                <a:solidFill>
-                  <a:srgbClr val="5B6170"/>
-                </a:solidFill>
-              </a:rPr>
-              <a:t>filtration</a:t>
-            </a:r>
-          </a:p>
-        </p:txBody>
-      </p:sp>
-      <p:sp>
-        <p:nvSpPr>
-          <p:cNvPr id="124" name="Advantage Motion"/>
-          <p:cNvSpPr txBox="1"/>
-          <p:nvPr/>
-        </p:nvSpPr>
-        <p:spPr>
-          <a:xfrm>
-            <a:off x="8362188" y="4700016"/>
-            <a:ext cx="1067562" cy="868680"/>
-          </a:xfrm>
-          <a:prstGeom prst="roundRect">
-            <a:avLst>
-              <a:gd name="adj" fmla="val 14000"/>
-            </a:avLst>
-          </a:prstGeom>
-          <a:solidFill>
-            <a:srgbClr val="EEF1F8"/>
-          </a:solidFill>
-          <a:ln>
-            <a:noFill/>
-          </a:ln>
-        </p:spPr>
-        <p:txBody>
-          <a:bodyPr wrap="square" lIns="36576" tIns="36576" rIns="36576" bIns="36576" anchor="ctr">
-            <a:noAutofit/>
-          </a:bodyPr>
-          <a:lstStyle/>
-          <a:p>
-            <a:pPr algn="ctr" marL="0" indent="0">
-              <a:spcBef>
-                <a:spcPts val="0"/>
-              </a:spcBef>
-              <a:spcAft>
-                <a:spcPts val="100"/>
-              </a:spcAft>
-              <a:buNone/>
-            </a:pPr>
-            <a:r>
-              <a:rPr lang="en-US" sz="1400" b="1" dirty="0">
-                <a:solidFill>
-                  <a:srgbClr val="213C80"/>
-                </a:solidFill>
-              </a:rPr>
-              <a:t>Motion</a:t>
-            </a:r>
-          </a:p>
-          <a:p>
-            <a:pPr algn="ctr" marL="0" indent="0">
-              <a:spcBef>
-                <a:spcPts val="0"/>
-              </a:spcBef>
-              <a:spcAft>
-                <a:spcPts val="0"/>
-              </a:spcAft>
-              <a:buNone/>
-            </a:pPr>
-            <a:r>
-              <a:rPr lang="en-US" sz="1000" dirty="0">
-                <a:solidFill>
-                  <a:srgbClr val="5B6170"/>
-                </a:solidFill>
-              </a:rPr>
-              <a:t>scaling</a:t>
-            </a:r>
-          </a:p>
-        </p:txBody>
-      </p:sp>
-      <p:sp>
-        <p:nvSpPr>
-          <p:cNvPr id="125" name="Advantage Wristed"/>
-          <p:cNvSpPr txBox="1"/>
-          <p:nvPr/>
-        </p:nvSpPr>
-        <p:spPr>
-          <a:xfrm>
-            <a:off x="9566910" y="4700016"/>
-            <a:ext cx="1067562" cy="868680"/>
-          </a:xfrm>
-          <a:prstGeom prst="roundRect">
-            <a:avLst>
-              <a:gd name="adj" fmla="val 14000"/>
-            </a:avLst>
-          </a:prstGeom>
-          <a:solidFill>
-            <a:srgbClr val="EEF1F8"/>
-          </a:solidFill>
-          <a:ln>
-            <a:noFill/>
-          </a:ln>
-        </p:spPr>
-        <p:txBody>
-          <a:bodyPr wrap="square" lIns="36576" tIns="36576" rIns="36576" bIns="36576" anchor="ctr">
-            <a:noAutofit/>
-          </a:bodyPr>
-          <a:lstStyle/>
-          <a:p>
-            <a:pPr algn="ctr" marL="0" indent="0">
-              <a:spcBef>
-                <a:spcPts val="0"/>
-              </a:spcBef>
-              <a:spcAft>
-                <a:spcPts val="100"/>
-              </a:spcAft>
-              <a:buNone/>
-            </a:pPr>
-            <a:r>
-              <a:rPr lang="en-US" sz="1400" b="1" dirty="0">
-                <a:solidFill>
-                  <a:srgbClr val="213C80"/>
-                </a:solidFill>
-              </a:rPr>
-              <a:t>Wristed</a:t>
-            </a:r>
-          </a:p>
-          <a:p>
-            <a:pPr algn="ctr" marL="0" indent="0">
-              <a:spcBef>
-                <a:spcPts val="0"/>
-              </a:spcBef>
-              <a:spcAft>
-                <a:spcPts val="0"/>
-              </a:spcAft>
-              <a:buNone/>
-            </a:pPr>
-            <a:r>
-              <a:rPr lang="en-US" sz="1000" dirty="0">
-                <a:solidFill>
-                  <a:srgbClr val="5B6170"/>
-                </a:solidFill>
-              </a:rPr>
-              <a:t>articulating</a:t>
-            </a:r>
-          </a:p>
-          <a:p>
-            <a:pPr algn="ctr" marL="0" indent="0">
-              <a:spcBef>
-                <a:spcPts val="0"/>
-              </a:spcBef>
-              <a:spcAft>
-                <a:spcPts val="0"/>
-              </a:spcAft>
-              <a:buNone/>
-            </a:pPr>
-            <a:r>
-              <a:rPr lang="en-US" sz="1000" dirty="0">
-                <a:solidFill>
-                  <a:srgbClr val="5B6170"/>
-                </a:solidFill>
-              </a:rPr>
-              <a:t>instruments</a:t>
-            </a:r>
-          </a:p>
-        </p:txBody>
-      </p:sp>
-      <p:sp>
-        <p:nvSpPr>
-          <p:cNvPr id="126" name="Section Title 30"/>
+          <p:cNvPr id="125" name="Section Title 30"/>
           <p:cNvSpPr>
             <a:spLocks noGrp="1"/>
           </p:cNvSpPr>
@@ -8116,7 +7323,7 @@
         </p:nvSpPr>
         <p:spPr>
           <a:xfrm>
-            <a:off x="5952744" y="5888736"/>
+            <a:off x="5952744" y="4224528"/>
             <a:ext cx="4681728" cy="384048"/>
           </a:xfrm>
         </p:spPr>
@@ -8144,26 +7351,26 @@
       </p:sp>
       <p:graphicFrame>
         <p:nvGraphicFramePr>
-          <p:cNvPr id="127" name="Outcomes table"/>
+          <p:cNvPr id="126" name="Outcomes table"/>
           <p:cNvGraphicFramePr>
             <a:graphicFrameLocks noGrp="1"/>
           </p:cNvGraphicFramePr>
           <p:nvPr/>
         </p:nvGraphicFramePr>
         <p:xfrm>
-          <a:off x="5952744" y="6345936"/>
-          <a:ext cx="4681728" cy="3383280"/>
+          <a:off x="5952744" y="4681728"/>
+          <a:ext cx="4681728" cy="3877056"/>
         </p:xfrm>
         <a:graphic>
           <a:graphicData uri="http://schemas.openxmlformats.org/drawingml/2006/table">
             <a:tbl>
               <a:tblPr firstRow="1" bandRow="1"/>
               <a:tblGrid>
-                <a:gridCol w="1243584"/>
-                <a:gridCol w="1627632"/>
-                <a:gridCol w="1810512"/>
+                <a:gridCol w="1298448"/>
+                <a:gridCol w="1591056"/>
+                <a:gridCol w="1792224"/>
               </a:tblGrid>
-              <a:tr h="329184">
+              <a:tr h="384048">
                 <a:tc>
                   <a:txBody>
                     <a:bodyPr/>
@@ -8179,7 +7386,7 @@
                         <a:buNone/>
                       </a:pPr>
                       <a:r>
-                        <a:rPr lang="en-US" sz="1050" b="1" dirty="0">
+                        <a:rPr lang="en-US" sz="1200" b="1" dirty="0">
                           <a:solidFill>
                             <a:srgbClr val="FFFFFF"/>
                           </a:solidFill>
@@ -8229,7 +7436,7 @@
                         <a:buNone/>
                       </a:pPr>
                       <a:r>
-                        <a:rPr lang="en-US" sz="1050" b="1" dirty="0">
+                        <a:rPr lang="en-US" sz="1200" b="1" dirty="0">
                           <a:solidFill>
                             <a:srgbClr val="FFFFFF"/>
                           </a:solidFill>
@@ -8279,7 +7486,7 @@
                         <a:buNone/>
                       </a:pPr>
                       <a:r>
-                        <a:rPr lang="en-US" sz="1050" b="1" dirty="0">
+                        <a:rPr lang="en-US" sz="1200" b="1" dirty="0">
                           <a:solidFill>
                             <a:srgbClr val="FFFFFF"/>
                           </a:solidFill>
@@ -8315,7 +7522,7 @@
                   </a:tcPr>
                 </a:tc>
               </a:tr>
-              <a:tr h="365760">
+              <a:tr h="420624">
                 <a:tc>
                   <a:txBody>
                     <a:bodyPr/>
@@ -8331,7 +7538,7 @@
                         <a:buNone/>
                       </a:pPr>
                       <a:r>
-                        <a:rPr lang="en-US" sz="1000" b="1" dirty="0"/>
+                        <a:rPr lang="en-US" sz="1150" b="1" dirty="0"/>
                         <a:t>Blood loss</a:t>
                       </a:r>
                     </a:p>
@@ -8375,7 +7582,7 @@
                         <a:buNone/>
                       </a:pPr>
                       <a:r>
-                        <a:rPr lang="en-US" sz="1000" b="1" dirty="0">
+                        <a:rPr lang="en-US" sz="1150" b="1" dirty="0">
                           <a:solidFill>
                             <a:srgbClr val="1E7B3C"/>
                           </a:solidFill>
@@ -8383,7 +7590,7 @@
                         <a:t xml:space="preserve">▼ </a:t>
                       </a:r>
                       <a:r>
-                        <a:rPr lang="en-US" sz="1000" dirty="0">
+                        <a:rPr lang="en-US" sz="1150" dirty="0">
                           <a:solidFill>
                             <a:srgbClr val="1E7B3C"/>
                           </a:solidFill>
@@ -8431,7 +7638,7 @@
                         <a:buNone/>
                       </a:pPr>
                       <a:r>
-                        <a:rPr lang="en-US" sz="1000" b="1" dirty="0">
+                        <a:rPr lang="en-US" sz="1150" b="1" dirty="0">
                           <a:solidFill>
                             <a:srgbClr val="1E7B3C"/>
                           </a:solidFill>
@@ -8439,7 +7646,7 @@
                         <a:t xml:space="preserve">▼ </a:t>
                       </a:r>
                       <a:r>
-                        <a:rPr lang="en-US" sz="1000" dirty="0">
+                        <a:rPr lang="en-US" sz="1150" dirty="0">
                           <a:solidFill>
                             <a:srgbClr val="1E7B3C"/>
                           </a:solidFill>
@@ -8473,7 +7680,7 @@
                   </a:tcPr>
                 </a:tc>
               </a:tr>
-              <a:tr h="530352">
+              <a:tr h="603504">
                 <a:tc>
                   <a:txBody>
                     <a:bodyPr/>
@@ -8489,7 +7696,7 @@
                         <a:buNone/>
                       </a:pPr>
                       <a:r>
-                        <a:rPr lang="en-US" sz="1000" b="1" dirty="0"/>
+                        <a:rPr lang="en-US" sz="1150" b="1" dirty="0"/>
                         <a:t>Complications</a:t>
                       </a:r>
                     </a:p>
@@ -8535,7 +7742,7 @@
                         <a:buNone/>
                       </a:pPr>
                       <a:r>
-                        <a:rPr lang="en-US" sz="1000" b="1" dirty="0">
+                        <a:rPr lang="en-US" sz="1150" b="1" dirty="0">
                           <a:solidFill>
                             <a:srgbClr val="1E7B3C"/>
                           </a:solidFill>
@@ -8543,7 +7750,7 @@
                         <a:t xml:space="preserve">▼ </a:t>
                       </a:r>
                       <a:r>
-                        <a:rPr lang="en-US" sz="1000" dirty="0">
+                        <a:rPr lang="en-US" sz="1150" dirty="0">
                           <a:solidFill>
                             <a:srgbClr val="1E7B3C"/>
                           </a:solidFill>
@@ -8593,7 +7800,7 @@
                         <a:buNone/>
                       </a:pPr>
                       <a:r>
-                        <a:rPr lang="en-US" sz="1000" b="1" dirty="0">
+                        <a:rPr lang="en-US" sz="1150" b="1" dirty="0">
                           <a:solidFill>
                             <a:srgbClr val="5B6170"/>
                           </a:solidFill>
@@ -8601,7 +7808,7 @@
                         <a:t xml:space="preserve">= </a:t>
                       </a:r>
                       <a:r>
-                        <a:rPr lang="en-US" sz="1000" dirty="0"/>
+                        <a:rPr lang="en-US" sz="1150" dirty="0"/>
                         <a:t>Similar overall, major &amp; fistula</a:t>
                       </a:r>
                     </a:p>
@@ -8633,7 +7840,7 @@
                   </a:tcPr>
                 </a:tc>
               </a:tr>
-              <a:tr h="365760">
+              <a:tr h="420624">
                 <a:tc>
                   <a:txBody>
                     <a:bodyPr/>
@@ -8649,7 +7856,7 @@
                         <a:buNone/>
                       </a:pPr>
                       <a:r>
-                        <a:rPr lang="en-US" sz="1000" b="1" dirty="0"/>
+                        <a:rPr lang="en-US" sz="1150" b="1" dirty="0"/>
                         <a:t>Hospital stay</a:t>
                       </a:r>
                     </a:p>
@@ -8693,7 +7900,7 @@
                         <a:buNone/>
                       </a:pPr>
                       <a:r>
-                        <a:rPr lang="en-US" sz="1000" b="1" dirty="0">
+                        <a:rPr lang="en-US" sz="1150" b="1" dirty="0">
                           <a:solidFill>
                             <a:srgbClr val="1E7B3C"/>
                           </a:solidFill>
@@ -8701,7 +7908,7 @@
                         <a:t xml:space="preserve">▼ </a:t>
                       </a:r>
                       <a:r>
-                        <a:rPr lang="en-US" sz="1000" dirty="0">
+                        <a:rPr lang="en-US" sz="1150" dirty="0">
                           <a:solidFill>
                             <a:srgbClr val="1E7B3C"/>
                           </a:solidFill>
@@ -8749,7 +7956,7 @@
                         <a:buNone/>
                       </a:pPr>
                       <a:r>
-                        <a:rPr lang="en-US" sz="1000" b="1" dirty="0">
+                        <a:rPr lang="en-US" sz="1150" b="1" dirty="0">
                           <a:solidFill>
                             <a:srgbClr val="1E7B3C"/>
                           </a:solidFill>
@@ -8757,7 +7964,7 @@
                         <a:t xml:space="preserve">▼ </a:t>
                       </a:r>
                       <a:r>
-                        <a:rPr lang="en-US" sz="1000" dirty="0">
+                        <a:rPr lang="en-US" sz="1150" dirty="0">
                           <a:solidFill>
                             <a:srgbClr val="1E7B3C"/>
                           </a:solidFill>
@@ -8791,7 +7998,7 @@
                   </a:tcPr>
                 </a:tc>
               </a:tr>
-              <a:tr h="365760">
+              <a:tr h="420624">
                 <a:tc>
                   <a:txBody>
                     <a:bodyPr/>
@@ -8807,7 +8014,7 @@
                         <a:buNone/>
                       </a:pPr>
                       <a:r>
-                        <a:rPr lang="en-US" sz="1000" b="1" dirty="0"/>
+                        <a:rPr lang="en-US" sz="1150" b="1" dirty="0"/>
                         <a:t>Conversion to open</a:t>
                       </a:r>
                     </a:p>
@@ -8853,7 +8060,7 @@
                         <a:buNone/>
                       </a:pPr>
                       <a:r>
-                        <a:rPr lang="en-US" sz="1000" dirty="0">
+                        <a:rPr lang="en-US" sz="1150" dirty="0">
                           <a:solidFill>
                             <a:srgbClr val="5B6170"/>
                           </a:solidFill>
@@ -8903,7 +8110,7 @@
                         <a:buNone/>
                       </a:pPr>
                       <a:r>
-                        <a:rPr lang="en-US" sz="1000" b="1" dirty="0">
+                        <a:rPr lang="en-US" sz="1150" b="1" dirty="0">
                           <a:solidFill>
                             <a:srgbClr val="1E7B3C"/>
                           </a:solidFill>
@@ -8911,7 +8118,7 @@
                         <a:t xml:space="preserve">▼ </a:t>
                       </a:r>
                       <a:r>
-                        <a:rPr lang="en-US" sz="1000" dirty="0">
+                        <a:rPr lang="en-US" sz="1150" dirty="0">
                           <a:solidFill>
                             <a:srgbClr val="1E7B3C"/>
                           </a:solidFill>
@@ -8947,7 +8154,7 @@
                   </a:tcPr>
                 </a:tc>
               </a:tr>
-              <a:tr h="530352">
+              <a:tr h="603504">
                 <a:tc>
                   <a:txBody>
                     <a:bodyPr/>
@@ -8963,7 +8170,7 @@
                         <a:buNone/>
                       </a:pPr>
                       <a:r>
-                        <a:rPr lang="en-US" sz="1000" b="1" dirty="0"/>
+                        <a:rPr lang="en-US" sz="1150" b="1" dirty="0"/>
                         <a:t>Spleen preservation</a:t>
                       </a:r>
                     </a:p>
@@ -9007,7 +8214,7 @@
                         <a:buNone/>
                       </a:pPr>
                       <a:r>
-                        <a:rPr lang="en-US" sz="1000" b="1" dirty="0">
+                        <a:rPr lang="en-US" sz="1150" b="1" dirty="0">
                           <a:solidFill>
                             <a:srgbClr val="1E7B3C"/>
                           </a:solidFill>
@@ -9015,7 +8222,7 @@
                         <a:t xml:space="preserve">▲ </a:t>
                       </a:r>
                       <a:r>
-                        <a:rPr lang="en-US" sz="1000" dirty="0">
+                        <a:rPr lang="en-US" sz="1150" dirty="0">
                           <a:solidFill>
                             <a:srgbClr val="1E7B3C"/>
                           </a:solidFill>
@@ -9063,7 +8270,7 @@
                         <a:buNone/>
                       </a:pPr>
                       <a:r>
-                        <a:rPr lang="en-US" sz="1000" b="1" dirty="0">
+                        <a:rPr lang="en-US" sz="1150" b="1" dirty="0">
                           <a:solidFill>
                             <a:srgbClr val="1E7B3C"/>
                           </a:solidFill>
@@ -9071,7 +8278,7 @@
                         <a:t xml:space="preserve">▲ </a:t>
                       </a:r>
                       <a:r>
-                        <a:rPr lang="en-US" sz="1000" dirty="0">
+                        <a:rPr lang="en-US" sz="1150" dirty="0">
                           <a:solidFill>
                             <a:srgbClr val="1E7B3C"/>
                           </a:solidFill>
@@ -9105,7 +8312,7 @@
                   </a:tcPr>
                 </a:tc>
               </a:tr>
-              <a:tr h="530352">
+              <a:tr h="603504">
                 <a:tc>
                   <a:txBody>
                     <a:bodyPr/>
@@ -9121,7 +8328,7 @@
                         <a:buNone/>
                       </a:pPr>
                       <a:r>
-                        <a:rPr lang="en-US" sz="1000" b="1" dirty="0"/>
+                        <a:rPr lang="en-US" sz="1150" b="1" dirty="0"/>
                         <a:t>Oncological</a:t>
                       </a:r>
                     </a:p>
@@ -9167,7 +8374,7 @@
                         <a:buNone/>
                       </a:pPr>
                       <a:r>
-                        <a:rPr lang="en-US" sz="1000" b="1" dirty="0">
+                        <a:rPr lang="en-US" sz="1150" b="1" dirty="0">
                           <a:solidFill>
                             <a:srgbClr val="5B6170"/>
                           </a:solidFill>
@@ -9175,7 +8382,7 @@
                         <a:t xml:space="preserve">= </a:t>
                       </a:r>
                       <a:r>
-                        <a:rPr lang="en-US" sz="1000" dirty="0"/>
+                        <a:rPr lang="en-US" sz="1150" dirty="0"/>
                         <a:t>Non-inferior R0 and LN yield (MIDP)</a:t>
                       </a:r>
                     </a:p>
@@ -9221,7 +8428,7 @@
                         <a:buNone/>
                       </a:pPr>
                       <a:r>
-                        <a:rPr lang="en-US" sz="1000" b="1" dirty="0">
+                        <a:rPr lang="en-US" sz="1150" b="1" dirty="0">
                           <a:solidFill>
                             <a:srgbClr val="1E7B3C"/>
                           </a:solidFill>
@@ -9229,7 +8436,7 @@
                         <a:t xml:space="preserve">▲ </a:t>
                       </a:r>
                       <a:r>
-                        <a:rPr lang="en-US" sz="1000" dirty="0">
+                        <a:rPr lang="en-US" sz="1150" dirty="0">
                           <a:solidFill>
                             <a:srgbClr val="1E7B3C"/>
                           </a:solidFill>
@@ -9265,7 +8472,7 @@
                   </a:tcPr>
                 </a:tc>
               </a:tr>
-              <a:tr h="365760">
+              <a:tr h="420624">
                 <a:tc>
                   <a:txBody>
                     <a:bodyPr/>
@@ -9281,7 +8488,7 @@
                         <a:buNone/>
                       </a:pPr>
                       <a:r>
-                        <a:rPr lang="en-US" sz="1000" b="1" dirty="0"/>
+                        <a:rPr lang="en-US" sz="1150" b="1" dirty="0"/>
                         <a:t>Operative time</a:t>
                       </a:r>
                     </a:p>
@@ -9325,7 +8532,7 @@
                         <a:buNone/>
                       </a:pPr>
                       <a:r>
-                        <a:rPr lang="en-US" sz="1000" b="1" dirty="0">
+                        <a:rPr lang="en-US" sz="1150" b="1" dirty="0">
                           <a:solidFill>
                             <a:srgbClr val="5B6170"/>
                           </a:solidFill>
@@ -9333,7 +8540,7 @@
                         <a:t xml:space="preserve">= </a:t>
                       </a:r>
                       <a:r>
-                        <a:rPr lang="en-US" sz="1000" dirty="0"/>
+                        <a:rPr lang="en-US" sz="1150" dirty="0"/>
                         <a:t>Conflicting</a:t>
                       </a:r>
                     </a:p>
@@ -9377,7 +8584,7 @@
                         <a:buNone/>
                       </a:pPr>
                       <a:r>
-                        <a:rPr lang="en-US" sz="1000" b="1" dirty="0">
+                        <a:rPr lang="en-US" sz="1150" b="1" dirty="0">
                           <a:solidFill>
                             <a:srgbClr val="B45309"/>
                           </a:solidFill>
@@ -9385,7 +8592,7 @@
                         <a:t xml:space="preserve">▲ </a:t>
                       </a:r>
                       <a:r>
-                        <a:rPr lang="en-US" sz="1000" dirty="0">
+                        <a:rPr lang="en-US" sz="1150" dirty="0">
                           <a:solidFill>
                             <a:srgbClr val="B45309"/>
                           </a:solidFill>
@@ -9425,13 +8632,13 @@
       </p:graphicFrame>
       <p:sp>
         <p:nvSpPr>
-          <p:cNvPr id="128" name="Legend"/>
+          <p:cNvPr id="127" name="Legend"/>
           <p:cNvSpPr txBox="1"/>
           <p:nvPr/>
         </p:nvSpPr>
         <p:spPr>
           <a:xfrm>
-            <a:off x="5952744" y="9802368"/>
+            <a:off x="5952744" y="8631936"/>
             <a:ext cx="4681728" cy="274320"/>
           </a:xfrm>
           <a:prstGeom prst="rect">
@@ -9510,14 +8717,14 @@
       </p:sp>
       <p:sp>
         <p:nvSpPr>
-          <p:cNvPr id="129" name="Stat 1 day"/>
+          <p:cNvPr id="128" name="Stat 1 day"/>
           <p:cNvSpPr txBox="1"/>
           <p:nvPr/>
         </p:nvSpPr>
         <p:spPr>
           <a:xfrm>
-            <a:off x="5952744" y="10186416"/>
-            <a:ext cx="1469136" cy="1207008"/>
+            <a:off x="5952744" y="9015984"/>
+            <a:ext cx="1469136" cy="1371600"/>
           </a:xfrm>
           <a:prstGeom prst="roundRect">
             <a:avLst>
@@ -9547,7 +8754,7 @@
               <a:buNone/>
             </a:pPr>
             <a:r>
-              <a:rPr lang="en-US" sz="2400" b="1" dirty="0">
+              <a:rPr lang="en-US" sz="2500" b="1" dirty="0">
                 <a:solidFill>
                   <a:srgbClr val="FFFFFF"/>
                 </a:solidFill>
@@ -9566,7 +8773,7 @@
               <a:buNone/>
             </a:pPr>
             <a:r>
-              <a:rPr lang="en-US" sz="1000" dirty="0">
+              <a:rPr lang="en-US" sz="1150" dirty="0">
                 <a:solidFill>
                   <a:srgbClr val="FFFFFF"/>
                 </a:solidFill>
@@ -9585,7 +8792,7 @@
               <a:buNone/>
             </a:pPr>
             <a:r>
-              <a:rPr lang="en-US" sz="1000" dirty="0">
+              <a:rPr lang="en-US" sz="1150" dirty="0">
                 <a:solidFill>
                   <a:srgbClr val="FFFFFF"/>
                 </a:solidFill>
@@ -9597,14 +8804,14 @@
       </p:sp>
       <p:sp>
         <p:nvSpPr>
-          <p:cNvPr id="130" name="Stat 0%"/>
+          <p:cNvPr id="129" name="Stat 0%"/>
           <p:cNvSpPr txBox="1"/>
           <p:nvPr/>
         </p:nvSpPr>
         <p:spPr>
           <a:xfrm>
-            <a:off x="7559040" y="10186416"/>
-            <a:ext cx="1469136" cy="1207008"/>
+            <a:off x="7559040" y="9015984"/>
+            <a:ext cx="1469136" cy="1371600"/>
           </a:xfrm>
           <a:prstGeom prst="roundRect">
             <a:avLst>
@@ -9634,7 +8841,7 @@
               <a:buNone/>
             </a:pPr>
             <a:r>
-              <a:rPr lang="en-US" sz="2400" b="1" dirty="0">
+              <a:rPr lang="en-US" sz="2500" b="1" dirty="0">
                 <a:solidFill>
                   <a:srgbClr val="FFFFFF"/>
                 </a:solidFill>
@@ -9653,7 +8860,7 @@
               <a:buNone/>
             </a:pPr>
             <a:r>
-              <a:rPr lang="en-US" sz="1000" dirty="0">
+              <a:rPr lang="en-US" sz="1150" dirty="0">
                 <a:solidFill>
                   <a:srgbClr val="FFFFFF"/>
                 </a:solidFill>
@@ -9672,7 +8879,7 @@
               <a:buNone/>
             </a:pPr>
             <a:r>
-              <a:rPr lang="en-US" sz="1000" dirty="0">
+              <a:rPr lang="en-US" sz="1150" dirty="0">
                 <a:solidFill>
                   <a:srgbClr val="FFFFFF"/>
                 </a:solidFill>
@@ -9684,14 +8891,14 @@
       </p:sp>
       <p:sp>
         <p:nvSpPr>
-          <p:cNvPr id="131" name="Stat +30 min"/>
+          <p:cNvPr id="130" name="Stat +30 min"/>
           <p:cNvSpPr txBox="1"/>
           <p:nvPr/>
         </p:nvSpPr>
         <p:spPr>
           <a:xfrm>
-            <a:off x="9165336" y="10186416"/>
-            <a:ext cx="1469136" cy="1207008"/>
+            <a:off x="9165336" y="9015984"/>
+            <a:ext cx="1469136" cy="1371600"/>
           </a:xfrm>
           <a:prstGeom prst="roundRect">
             <a:avLst>
@@ -9721,12 +8928,12 @@
               <a:buNone/>
             </a:pPr>
             <a:r>
-              <a:rPr lang="en-US" sz="2400" b="1" dirty="0">
+              <a:rPr lang="en-US" sz="2500" b="1" dirty="0">
                 <a:solidFill>
                   <a:srgbClr val="213C80"/>
                 </a:solidFill>
               </a:rPr>
-              <a:t>+30 min</a:t>
+              <a:t>+30 min</a:t>
             </a:r>
           </a:p>
           <a:p>
@@ -9740,7 +8947,7 @@
               <a:buNone/>
             </a:pPr>
             <a:r>
-              <a:rPr lang="en-US" sz="1000" dirty="0">
+              <a:rPr lang="en-US" sz="1150" dirty="0">
                 <a:solidFill>
                   <a:srgbClr val="213C80"/>
                 </a:solidFill>
@@ -9759,7 +8966,7 @@
               <a:buNone/>
             </a:pPr>
             <a:r>
-              <a:rPr lang="en-US" sz="1000" dirty="0">
+              <a:rPr lang="en-US" sz="1150" dirty="0">
                 <a:solidFill>
                   <a:srgbClr val="213C80"/>
                 </a:solidFill>
@@ -9771,7 +8978,7 @@
       </p:sp>
       <p:sp>
         <p:nvSpPr>
-          <p:cNvPr id="132" name="Section Title 34"/>
+          <p:cNvPr id="131" name="Section Title 34"/>
           <p:cNvSpPr>
             <a:spLocks noGrp="1"/>
           </p:cNvSpPr>
@@ -9781,7 +8988,7 @@
         </p:nvSpPr>
         <p:spPr>
           <a:xfrm>
-            <a:off x="5952744" y="11740896"/>
+            <a:off x="5952744" y="10799064"/>
             <a:ext cx="4681728" cy="384048"/>
           </a:xfrm>
         </p:spPr>
@@ -9809,14 +9016,14 @@
       </p:sp>
       <p:sp>
         <p:nvSpPr>
-          <p:cNvPr id="133" name="Cost chip Operative cost"/>
+          <p:cNvPr id="132" name="Cost chip Operative cost"/>
           <p:cNvSpPr txBox="1"/>
           <p:nvPr/>
         </p:nvSpPr>
         <p:spPr>
           <a:xfrm>
-            <a:off x="5952744" y="12216384"/>
-            <a:ext cx="1469136" cy="713232"/>
+            <a:off x="5952744" y="11274552"/>
+            <a:ext cx="1469136" cy="841248"/>
           </a:xfrm>
           <a:prstGeom prst="roundRect">
             <a:avLst>
@@ -9846,7 +9053,7 @@
               <a:buNone/>
             </a:pPr>
             <a:r>
-              <a:rPr lang="en-US" sz="1000" dirty="0">
+              <a:rPr lang="en-US" sz="1100" dirty="0">
                 <a:solidFill>
                   <a:srgbClr val="5B6170"/>
                 </a:solidFill>
@@ -9877,14 +9084,14 @@
       </p:sp>
       <p:sp>
         <p:nvSpPr>
-          <p:cNvPr id="134" name="Cost chip Overall cost"/>
+          <p:cNvPr id="133" name="Cost chip Overall cost"/>
           <p:cNvSpPr txBox="1"/>
           <p:nvPr/>
         </p:nvSpPr>
         <p:spPr>
           <a:xfrm>
-            <a:off x="7559040" y="12216384"/>
-            <a:ext cx="1469136" cy="713232"/>
+            <a:off x="7559040" y="11274552"/>
+            <a:ext cx="1469136" cy="841248"/>
           </a:xfrm>
           <a:prstGeom prst="roundRect">
             <a:avLst>
@@ -9914,7 +9121,7 @@
               <a:buNone/>
             </a:pPr>
             <a:r>
-              <a:rPr lang="en-US" sz="1000" dirty="0">
+              <a:rPr lang="en-US" sz="1100" dirty="0">
                 <a:solidFill>
                   <a:srgbClr val="5B6170"/>
                 </a:solidFill>
@@ -9938,21 +9145,21 @@
                   <a:srgbClr val="213C80"/>
                 </a:solidFill>
               </a:rPr>
-              <a:t>RDP ≤ LDP &lt; ODP</a:t>
+              <a:t>RDP ≤ LDP &lt; ODP</a:t>
             </a:r>
           </a:p>
         </p:txBody>
       </p:sp>
       <p:sp>
         <p:nvSpPr>
-          <p:cNvPr id="135" name="Cost chip QALYs"/>
+          <p:cNvPr id="134" name="Cost chip QALYs"/>
           <p:cNvSpPr txBox="1"/>
           <p:nvPr/>
         </p:nvSpPr>
         <p:spPr>
           <a:xfrm>
-            <a:off x="9165336" y="12216384"/>
-            <a:ext cx="1469136" cy="713232"/>
+            <a:off x="9165336" y="11274552"/>
+            <a:ext cx="1469136" cy="841248"/>
           </a:xfrm>
           <a:prstGeom prst="roundRect">
             <a:avLst>
@@ -9982,7 +9189,7 @@
               <a:buNone/>
             </a:pPr>
             <a:r>
-              <a:rPr lang="en-US" sz="1000" dirty="0">
+              <a:rPr lang="en-US" sz="1100" dirty="0">
                 <a:solidFill>
                   <a:srgbClr val="5B6170"/>
                 </a:solidFill>
@@ -10013,7 +9220,7 @@
       </p:sp>
       <p:sp>
         <p:nvSpPr>
-          <p:cNvPr id="136" name="Cost Text"/>
+          <p:cNvPr id="135" name="Cost Text"/>
           <p:cNvSpPr>
             <a:spLocks noGrp="1"/>
           </p:cNvSpPr>
@@ -10023,8 +9230,8 @@
         </p:nvSpPr>
         <p:spPr>
           <a:xfrm>
-            <a:off x="5952744" y="13057632"/>
-            <a:ext cx="4681728" cy="1920240"/>
+            <a:off x="5952744" y="12243816"/>
+            <a:ext cx="4681728" cy="2240280"/>
           </a:xfrm>
         </p:spPr>
         <p:txBody>
@@ -10047,15 +9254,15 @@
               <a:buChar char="•"/>
             </a:pPr>
             <a:r>
-              <a:rPr lang="en-US" sz="1200" dirty="0"/>
+              <a:rPr lang="en-US" sz="1350" dirty="0"/>
               <a:t xml:space="preserve">Higher instrument and platform costs are </a:t>
             </a:r>
             <a:r>
-              <a:rPr lang="en-US" sz="1200" b="1" dirty="0"/>
+              <a:rPr lang="en-US" sz="1350" b="1" dirty="0"/>
               <a:t>offset by shorter stay, fewer conversions and lower morbidity</a:t>
             </a:r>
             <a:r>
-              <a:rPr lang="en-US" sz="1200" dirty="0"/>
+              <a:rPr lang="en-US" sz="1350" dirty="0"/>
               <a:t>.</a:t>
             </a:r>
           </a:p>
@@ -10074,7 +9281,7 @@
               <a:buChar char="•"/>
             </a:pPr>
             <a:r>
-              <a:rPr lang="en-US" sz="1200" dirty="0"/>
+              <a:rPr lang="en-US" sz="1350" dirty="0"/>
               <a:t>Costs fall with case volume (learning curve, robot-specific instruments).</a:t>
             </a:r>
           </a:p>
@@ -10093,7 +9300,7 @@
               <a:buChar char="•"/>
             </a:pPr>
             <a:r>
-              <a:rPr lang="en-US" sz="1200" dirty="0"/>
+              <a:rPr lang="en-US" sz="1350" dirty="0"/>
               <a:t>Higher QALYs than LDP at similar cost, within the European acceptability threshold; supported by the multicentre ROBOCOSTES trial.</a:t>
             </a:r>
           </a:p>
@@ -10101,7 +9308,7 @@
       </p:sp>
       <p:sp>
         <p:nvSpPr>
-          <p:cNvPr id="137" name="Section Title 38"/>
+          <p:cNvPr id="136" name="Section Title 38"/>
           <p:cNvSpPr>
             <a:spLocks noGrp="1"/>
           </p:cNvSpPr>
@@ -10111,7 +9318,7 @@
         </p:nvSpPr>
         <p:spPr>
           <a:xfrm>
-            <a:off x="5952744" y="15069312"/>
+            <a:off x="5952744" y="14575536"/>
             <a:ext cx="4681728" cy="384048"/>
           </a:xfrm>
         </p:spPr>
@@ -10139,14 +9346,14 @@
       </p:sp>
       <p:sp>
         <p:nvSpPr>
-          <p:cNvPr id="138" name="Conclusion box"/>
+          <p:cNvPr id="137" name="Conclusion box"/>
           <p:cNvSpPr txBox="1"/>
           <p:nvPr/>
         </p:nvSpPr>
         <p:spPr>
           <a:xfrm>
-            <a:off x="5952744" y="15544800"/>
-            <a:ext cx="4681728" cy="1874520"/>
+            <a:off x="5952744" y="15051024"/>
+            <a:ext cx="4681728" cy="2240280"/>
           </a:xfrm>
           <a:prstGeom prst="roundRect">
             <a:avLst>
@@ -10176,7 +9383,7 @@
               <a:buNone/>
             </a:pPr>
             <a:r>
-              <a:rPr lang="en-US" sz="1250" b="1" dirty="0">
+              <a:rPr lang="en-US" sz="1400" b="1" dirty="0">
                 <a:solidFill>
                   <a:srgbClr val="FFFFFF"/>
                 </a:solidFill>
@@ -10195,7 +9402,7 @@
               <a:buNone/>
             </a:pPr>
             <a:r>
-              <a:rPr lang="en-US" sz="1200" dirty="0">
+              <a:rPr lang="en-US" sz="1350" dirty="0">
                 <a:solidFill>
                   <a:srgbClr val="FFFFFF"/>
                 </a:solidFill>
@@ -10207,7 +9414,7 @@
       </p:sp>
       <p:sp>
         <p:nvSpPr>
-          <p:cNvPr id="139" name="Reference"/>
+          <p:cNvPr id="138" name="Reference"/>
           <p:cNvSpPr>
             <a:spLocks noGrp="1"/>
           </p:cNvSpPr>
@@ -10217,7 +9424,7 @@
         </p:nvSpPr>
         <p:spPr>
           <a:xfrm>
-            <a:off x="5952744" y="17602200"/>
+            <a:off x="5952744" y="17474184"/>
             <a:ext cx="4681728" cy="566928"/>
           </a:xfrm>
         </p:spPr>

</xml_diff>